<commit_message>
feat: add timeline-aligned explainer video generation
</commit_message>
<xml_diff>
--- a/to_be_submitted_docs/答辩.pptx
+++ b/to_be_submitted_docs/答辩.pptx
@@ -2,30 +2,30 @@
 <file path=ppt/presentation.xml><?xml version="1.0" encoding="utf-8"?>
 <p:presentation xmlns:p="http://schemas.openxmlformats.org/presentationml/2006/main">
   <p:sldMasterIdLst>
-    <p:sldMasterId xmlns:r="http://schemas.openxmlformats.org/officeDocument/2006/relationships" id="2147483648" r:id="R97a7f4a99d774a28"/>
+    <p:sldMasterId xmlns:r="http://schemas.openxmlformats.org/officeDocument/2006/relationships" id="2147483648" r:id="R31539d53038e4e53"/>
   </p:sldMasterIdLst>
   <p:notesMasterIdLst>
-    <p:notesMasterId xmlns:r="http://schemas.openxmlformats.org/officeDocument/2006/relationships" r:id="R530350a191ee46b7"/>
+    <p:notesMasterId xmlns:r="http://schemas.openxmlformats.org/officeDocument/2006/relationships" r:id="R7e749ccb906a4321"/>
   </p:notesMasterIdLst>
   <p:sldIdLst>
-    <p:sldId xmlns:r="http://schemas.openxmlformats.org/officeDocument/2006/relationships" id="256" r:id="R07f00890d4614442"/>
-    <p:sldId xmlns:r="http://schemas.openxmlformats.org/officeDocument/2006/relationships" id="257" r:id="R60cdcddaaf8445ac"/>
-    <p:sldId xmlns:r="http://schemas.openxmlformats.org/officeDocument/2006/relationships" id="258" r:id="R4aeeb1b808594643"/>
-    <p:sldId xmlns:r="http://schemas.openxmlformats.org/officeDocument/2006/relationships" id="259" r:id="Rba6507c702db4f90"/>
-    <p:sldId xmlns:r="http://schemas.openxmlformats.org/officeDocument/2006/relationships" id="260" r:id="R486f33d80af54bc5"/>
-    <p:sldId xmlns:r="http://schemas.openxmlformats.org/officeDocument/2006/relationships" id="261" r:id="R56fba78970e04d21"/>
-    <p:sldId xmlns:r="http://schemas.openxmlformats.org/officeDocument/2006/relationships" id="262" r:id="Rf6075decd5ef4fdb"/>
-    <p:sldId xmlns:r="http://schemas.openxmlformats.org/officeDocument/2006/relationships" id="263" r:id="R94881ff5b21a48de"/>
-    <p:sldId xmlns:r="http://schemas.openxmlformats.org/officeDocument/2006/relationships" id="264" r:id="R041761894b41402c"/>
-    <p:sldId xmlns:r="http://schemas.openxmlformats.org/officeDocument/2006/relationships" id="265" r:id="R3ced831a14af4843"/>
-    <p:sldId xmlns:r="http://schemas.openxmlformats.org/officeDocument/2006/relationships" id="266" r:id="R8283c45428b1424b"/>
-    <p:sldId xmlns:r="http://schemas.openxmlformats.org/officeDocument/2006/relationships" id="267" r:id="R84ea5894751f46f6"/>
-    <p:sldId xmlns:r="http://schemas.openxmlformats.org/officeDocument/2006/relationships" id="268" r:id="Ra0fb9f01fe0c4b8a"/>
-    <p:sldId xmlns:r="http://schemas.openxmlformats.org/officeDocument/2006/relationships" id="269" r:id="Rad47342c2865465f"/>
-    <p:sldId xmlns:r="http://schemas.openxmlformats.org/officeDocument/2006/relationships" id="270" r:id="R1899a265972441d8"/>
-    <p:sldId xmlns:r="http://schemas.openxmlformats.org/officeDocument/2006/relationships" id="271" r:id="R24dc8c65c17d412a"/>
-    <p:sldId xmlns:r="http://schemas.openxmlformats.org/officeDocument/2006/relationships" id="272" r:id="Rf10d9a28a53c4b7c"/>
-    <p:sldId xmlns:r="http://schemas.openxmlformats.org/officeDocument/2006/relationships" id="273" r:id="R56b41bd34a424c33"/>
+    <p:sldId xmlns:r="http://schemas.openxmlformats.org/officeDocument/2006/relationships" id="256" r:id="R97b14a74f95a4c5b"/>
+    <p:sldId xmlns:r="http://schemas.openxmlformats.org/officeDocument/2006/relationships" id="257" r:id="R11f0fa14c9d04b27"/>
+    <p:sldId xmlns:r="http://schemas.openxmlformats.org/officeDocument/2006/relationships" id="258" r:id="Rf8334187efe34f71"/>
+    <p:sldId xmlns:r="http://schemas.openxmlformats.org/officeDocument/2006/relationships" id="259" r:id="Ree9da69487a846d8"/>
+    <p:sldId xmlns:r="http://schemas.openxmlformats.org/officeDocument/2006/relationships" id="260" r:id="R93d63278fa994ee4"/>
+    <p:sldId xmlns:r="http://schemas.openxmlformats.org/officeDocument/2006/relationships" id="261" r:id="Rccaf87845009455c"/>
+    <p:sldId xmlns:r="http://schemas.openxmlformats.org/officeDocument/2006/relationships" id="262" r:id="Rebb1f4bff4cf4904"/>
+    <p:sldId xmlns:r="http://schemas.openxmlformats.org/officeDocument/2006/relationships" id="263" r:id="R1e82a89f71874327"/>
+    <p:sldId xmlns:r="http://schemas.openxmlformats.org/officeDocument/2006/relationships" id="264" r:id="Rd7bcafd0e1fd4e2d"/>
+    <p:sldId xmlns:r="http://schemas.openxmlformats.org/officeDocument/2006/relationships" id="265" r:id="R0876bc9b13bf471b"/>
+    <p:sldId xmlns:r="http://schemas.openxmlformats.org/officeDocument/2006/relationships" id="266" r:id="Re0cc3ada60d540f3"/>
+    <p:sldId xmlns:r="http://schemas.openxmlformats.org/officeDocument/2006/relationships" id="267" r:id="Rdbc3f9c6d1154618"/>
+    <p:sldId xmlns:r="http://schemas.openxmlformats.org/officeDocument/2006/relationships" id="268" r:id="Rad2f39211f4f47d8"/>
+    <p:sldId xmlns:r="http://schemas.openxmlformats.org/officeDocument/2006/relationships" id="269" r:id="Rb673c5afdc2541c4"/>
+    <p:sldId xmlns:r="http://schemas.openxmlformats.org/officeDocument/2006/relationships" id="270" r:id="Rfa8077462380493b"/>
+    <p:sldId xmlns:r="http://schemas.openxmlformats.org/officeDocument/2006/relationships" id="271" r:id="Rdb86c78ead014094"/>
+    <p:sldId xmlns:r="http://schemas.openxmlformats.org/officeDocument/2006/relationships" id="272" r:id="R615f244074104ac9"/>
+    <p:sldId xmlns:r="http://schemas.openxmlformats.org/officeDocument/2006/relationships" id="273" r:id="R118c0b9ae397493a"/>
   </p:sldIdLst>
   <p:sldSz cx="12192000" cy="6858000"/>
   <p:notesSz cx="6858000" cy="9144000"/>
@@ -1740,7 +1740,7 @@
   </p:cSld>
   <p:clrMap bg1="lt1" tx1="dk1" bg2="lt2" tx2="dk2" accent1="accent1" accent2="accent2" accent3="accent3" accent4="accent4" accent5="accent5" accent6="accent6" hlink="hlink" folHlink="folHlink"/>
   <p:sldLayoutIdLst>
-    <p:sldLayoutId xmlns:r="http://schemas.openxmlformats.org/officeDocument/2006/relationships" id="2147483649" r:id="R8f7adfbabdc04ebe"/>
+    <p:sldLayoutId xmlns:r="http://schemas.openxmlformats.org/officeDocument/2006/relationships" id="2147483649" r:id="Reff123c7fe6943b5"/>
   </p:sldLayoutIdLst>
   <p:txStyles>
     <p:titleStyle>
@@ -3313,7 +3313,7 @@
         </p:spPr>
         <p:txBody>
           <a:bodyPr xmlns:a="http://schemas.openxmlformats.org/drawingml/2006/main" anchor="t">
-            <a:normAutofit/>
+            <a:normAutofit fontScale="100000"/>
           </a:bodyPr>
           <a:lstStyle xmlns:a="http://schemas.openxmlformats.org/drawingml/2006/main"/>
           <a:p xmlns:a="http://schemas.openxmlformats.org/drawingml/2006/main">
@@ -3337,7 +3337,7 @@
                 <a:ea typeface="微软雅黑"/>
                 <a:cs typeface="微软雅黑"/>
               </a:rPr>
-              <a:t>技术选型支撑本地运行、模型适配与桌面交付</a:t>
+              <a:t>技术选型支撑模型分工、媒体合成与桌面交付</a:t>
             </a:r>
           </a:p>
         </p:txBody>
@@ -4330,7 +4330,7 @@
                 <a:ea typeface="微软雅黑"/>
                 <a:cs typeface="微软雅黑"/>
               </a:rPr>
-              <a:t>DashScope / Qwen</a:t>
+              <a:t>文本 / 图片 / TTS</a:t>
             </a:r>
           </a:p>
           <a:p xmlns:a="http://schemas.openxmlformats.org/drawingml/2006/main">
@@ -4378,7 +4378,7 @@
                 <a:ea typeface="微软雅黑"/>
                 <a:cs typeface="微软雅黑"/>
               </a:rPr>
-              <a:t>多智能体调度</a:t>
+              <a:t>FFmpeg 本地视频合成</a:t>
             </a:r>
           </a:p>
         </p:txBody>
@@ -4711,7 +4711,7 @@
                 <a:ea typeface="微软雅黑"/>
                 <a:cs typeface="微软雅黑"/>
               </a:rPr>
-              <a:t>创新聚焦可追溯、可个性化、可验证</a:t>
+              <a:t>创新聚焦可追溯、可个性化、可验证、可扩展</a:t>
             </a:r>
           </a:p>
         </p:txBody>
@@ -5248,7 +5248,7 @@
                 <a:ea typeface="微软雅黑"/>
                 <a:cs typeface="微软雅黑"/>
               </a:rPr>
-              <a:t>来源约束的 7+1 流水线</a:t>
+              <a:t>真实语音时间轴讲解视频</a:t>
             </a:r>
           </a:p>
         </p:txBody>
@@ -5307,7 +5307,7 @@
                 <a:ea typeface="微软雅黑"/>
                 <a:cs typeface="微软雅黑"/>
               </a:rPr>
-              <a:t>结构校验、硬阻断与 SSE/任务进度全程可观测。</a:t>
+              <a:t>脚本同步给出视觉提示；图片按 TTS 时间点由 FFmpeg 合成 MP4。</a:t>
             </a:r>
           </a:p>
         </p:txBody>
@@ -5836,7 +5836,7 @@
           <p:nvPr/>
         </p:nvPicPr>
         <p:blipFill>
-          <a:blip xmlns:r="http://schemas.openxmlformats.org/officeDocument/2006/relationships" xmlns:a="http://schemas.openxmlformats.org/drawingml/2006/main" r:embed="R96b5aa0e084244e9"/>
+          <a:blip xmlns:r="http://schemas.openxmlformats.org/officeDocument/2006/relationships" xmlns:a="http://schemas.openxmlformats.org/drawingml/2006/main" r:embed="R630a8291e0e24322"/>
           <a:stretch xmlns:a="http://schemas.openxmlformats.org/drawingml/2006/main">
             <a:fillRect l="0" t="0" r="0" b="0"/>
           </a:stretch>
@@ -6743,7 +6743,7 @@
           <p:nvPr/>
         </p:nvPicPr>
         <p:blipFill>
-          <a:blip xmlns:r="http://schemas.openxmlformats.org/officeDocument/2006/relationships" xmlns:a="http://schemas.openxmlformats.org/drawingml/2006/main" r:embed="R724990e483914e2a"/>
+          <a:blip xmlns:r="http://schemas.openxmlformats.org/officeDocument/2006/relationships" xmlns:a="http://schemas.openxmlformats.org/drawingml/2006/main" r:embed="R6e217e51bca1499d"/>
           <a:stretch xmlns:a="http://schemas.openxmlformats.org/drawingml/2006/main">
             <a:fillRect l="0" t="0" r="0" b="0"/>
           </a:stretch>
@@ -7650,7 +7650,7 @@
           <p:nvPr/>
         </p:nvPicPr>
         <p:blipFill>
-          <a:blip xmlns:r="http://schemas.openxmlformats.org/officeDocument/2006/relationships" xmlns:a="http://schemas.openxmlformats.org/drawingml/2006/main" r:embed="R8ca69568ce6c4fbb"/>
+          <a:blip xmlns:r="http://schemas.openxmlformats.org/officeDocument/2006/relationships" xmlns:a="http://schemas.openxmlformats.org/drawingml/2006/main" r:embed="R04054776c0394234"/>
           <a:stretch xmlns:a="http://schemas.openxmlformats.org/drawingml/2006/main">
             <a:fillRect l="0" t="0" r="0" b="0"/>
           </a:stretch>
@@ -8361,7 +8361,7 @@
                 <a:ea typeface="微软雅黑"/>
                 <a:cs typeface="微软雅黑"/>
               </a:rPr>
-              <a:t>Studio 展示：7 类编排资产 + 独立播客管线</a:t>
+              <a:t>Studio 展示：7 类编排资产 + 播客 / 讲解视频管线</a:t>
             </a:r>
           </a:p>
         </p:txBody>
@@ -8569,7 +8569,7 @@
                 <a:ea typeface="微软雅黑"/>
                 <a:cs typeface="微软雅黑"/>
               </a:rPr>
-              <a:t>7 类资产共享画像与来源约束；播客由脚本、多说话人 TTS 和音频合成独立完成。</a:t>
+              <a:t>7 类资产共享画像与来源约束；播客脚本同步规划关键画面，并按真实语音时间轴合成本地 MP4。</a:t>
             </a:r>
           </a:p>
         </p:txBody>
@@ -8675,7 +8675,7 @@
           <p:nvPr/>
         </p:nvPicPr>
         <p:blipFill>
-          <a:blip xmlns:r="http://schemas.openxmlformats.org/officeDocument/2006/relationships" xmlns:a="http://schemas.openxmlformats.org/drawingml/2006/main" r:embed="R657380d7be6f4121"/>
+          <a:blip xmlns:r="http://schemas.openxmlformats.org/officeDocument/2006/relationships" xmlns:a="http://schemas.openxmlformats.org/drawingml/2006/main" r:embed="Rbe18694227054c7e"/>
           <a:stretch xmlns:a="http://schemas.openxmlformats.org/drawingml/2006/main">
             <a:fillRect l="0" t="0" r="0" b="0"/>
           </a:stretch>
@@ -8791,7 +8791,7 @@
           <p:nvPr/>
         </p:nvPicPr>
         <p:blipFill>
-          <a:blip xmlns:r="http://schemas.openxmlformats.org/officeDocument/2006/relationships" xmlns:a="http://schemas.openxmlformats.org/drawingml/2006/main" r:embed="R1c988731e8e44f40"/>
+          <a:blip xmlns:r="http://schemas.openxmlformats.org/officeDocument/2006/relationships" xmlns:a="http://schemas.openxmlformats.org/drawingml/2006/main" r:embed="R84059422180048b0"/>
           <a:stretch xmlns:a="http://schemas.openxmlformats.org/drawingml/2006/main">
             <a:fillRect l="0" t="0" r="0" b="0"/>
           </a:stretch>
@@ -8907,7 +8907,7 @@
           <p:nvPr/>
         </p:nvPicPr>
         <p:blipFill>
-          <a:blip xmlns:r="http://schemas.openxmlformats.org/officeDocument/2006/relationships" xmlns:a="http://schemas.openxmlformats.org/drawingml/2006/main" r:embed="R9eff76643bb246df"/>
+          <a:blip xmlns:r="http://schemas.openxmlformats.org/officeDocument/2006/relationships" xmlns:a="http://schemas.openxmlformats.org/drawingml/2006/main" r:embed="R45d0b2a0b84e40c9"/>
           <a:stretch xmlns:a="http://schemas.openxmlformats.org/drawingml/2006/main">
             <a:fillRect l="0" t="0" r="0" b="0"/>
           </a:stretch>
@@ -9023,7 +9023,7 @@
           <p:nvPr/>
         </p:nvPicPr>
         <p:blipFill>
-          <a:blip xmlns:r="http://schemas.openxmlformats.org/officeDocument/2006/relationships" xmlns:a="http://schemas.openxmlformats.org/drawingml/2006/main" r:embed="R0b6ed89f0cc14b11"/>
+          <a:blip xmlns:r="http://schemas.openxmlformats.org/officeDocument/2006/relationships" xmlns:a="http://schemas.openxmlformats.org/drawingml/2006/main" r:embed="Rd704390c3cca4eb3"/>
           <a:stretch xmlns:a="http://schemas.openxmlformats.org/drawingml/2006/main">
             <a:fillRect l="0" t="0" r="0" b="0"/>
           </a:stretch>
@@ -9139,7 +9139,7 @@
           <p:nvPr/>
         </p:nvPicPr>
         <p:blipFill>
-          <a:blip xmlns:r="http://schemas.openxmlformats.org/officeDocument/2006/relationships" xmlns:a="http://schemas.openxmlformats.org/drawingml/2006/main" r:embed="R5f576ce27fa2414d"/>
+          <a:blip xmlns:r="http://schemas.openxmlformats.org/officeDocument/2006/relationships" xmlns:a="http://schemas.openxmlformats.org/drawingml/2006/main" r:embed="Rf11f1eacb14f413c"/>
           <a:stretch xmlns:a="http://schemas.openxmlformats.org/drawingml/2006/main">
             <a:fillRect l="0" t="0" r="0" b="0"/>
           </a:stretch>
@@ -9255,7 +9255,7 @@
           <p:nvPr/>
         </p:nvPicPr>
         <p:blipFill>
-          <a:blip xmlns:r="http://schemas.openxmlformats.org/officeDocument/2006/relationships" xmlns:a="http://schemas.openxmlformats.org/drawingml/2006/main" r:embed="R17712a402f584527"/>
+          <a:blip xmlns:r="http://schemas.openxmlformats.org/officeDocument/2006/relationships" xmlns:a="http://schemas.openxmlformats.org/drawingml/2006/main" r:embed="Raeb684002a7549e9"/>
           <a:stretch xmlns:a="http://schemas.openxmlformats.org/drawingml/2006/main">
             <a:fillRect l="0" t="0" r="0" b="0"/>
           </a:stretch>
@@ -9371,7 +9371,7 @@
           <p:nvPr/>
         </p:nvPicPr>
         <p:blipFill>
-          <a:blip xmlns:r="http://schemas.openxmlformats.org/officeDocument/2006/relationships" xmlns:a="http://schemas.openxmlformats.org/drawingml/2006/main" r:embed="Rbf62a1c6673f47e5"/>
+          <a:blip xmlns:r="http://schemas.openxmlformats.org/officeDocument/2006/relationships" xmlns:a="http://schemas.openxmlformats.org/drawingml/2006/main" r:embed="R6465e8a7646141f6"/>
           <a:stretch xmlns:a="http://schemas.openxmlformats.org/drawingml/2006/main">
             <a:fillRect l="0" t="0" r="0" b="0"/>
           </a:stretch>
@@ -9473,7 +9473,7 @@
                 <a:ea typeface="微软雅黑"/>
                 <a:cs typeface="微软雅黑"/>
               </a:rPr>
-              <a:t>播客</a:t>
+              <a:t>播客 / 讲解视频</a:t>
             </a:r>
           </a:p>
         </p:txBody>
@@ -9487,7 +9487,8 @@
           <p:nvPr/>
         </p:nvPicPr>
         <p:blipFill>
-          <a:blip xmlns:r="http://schemas.openxmlformats.org/officeDocument/2006/relationships" xmlns:a="http://schemas.openxmlformats.org/drawingml/2006/main" r:embed="R36e78b139b764b98"/>
+          <a:blip xmlns:r="http://schemas.openxmlformats.org/officeDocument/2006/relationships" xmlns:a="http://schemas.openxmlformats.org/drawingml/2006/main" r:embed="Rd8945b4ee2b545ac"/>
+          <a:srcRect xmlns:a="http://schemas.openxmlformats.org/drawingml/2006/main" l="0" t="1947" r="0" b="1947"/>
           <a:stretch xmlns:a="http://schemas.openxmlformats.org/drawingml/2006/main">
             <a:fillRect l="0" t="0" r="0" b="0"/>
           </a:stretch>
@@ -10203,7 +10204,7 @@
           <p:nvPr/>
         </p:nvPicPr>
         <p:blipFill>
-          <a:blip xmlns:r="http://schemas.openxmlformats.org/officeDocument/2006/relationships" xmlns:a="http://schemas.openxmlformats.org/drawingml/2006/main" r:embed="Re671488f110140ab"/>
+          <a:blip xmlns:r="http://schemas.openxmlformats.org/officeDocument/2006/relationships" xmlns:a="http://schemas.openxmlformats.org/drawingml/2006/main" r:embed="R9ad65690639242aa"/>
           <a:stretch xmlns:a="http://schemas.openxmlformats.org/drawingml/2006/main">
             <a:fillRect l="0" t="0" r="0" b="0"/>
           </a:stretch>
@@ -10378,7 +10379,7 @@
           <p:nvPr/>
         </p:nvPicPr>
         <p:blipFill>
-          <a:blip xmlns:r="http://schemas.openxmlformats.org/officeDocument/2006/relationships" xmlns:a="http://schemas.openxmlformats.org/drawingml/2006/main" r:embed="Rbfb908d7424440f5"/>
+          <a:blip xmlns:r="http://schemas.openxmlformats.org/officeDocument/2006/relationships" xmlns:a="http://schemas.openxmlformats.org/drawingml/2006/main" r:embed="R9c56f0a2c1a14ec5"/>
           <a:stretch xmlns:a="http://schemas.openxmlformats.org/drawingml/2006/main">
             <a:fillRect l="0" t="0" r="0" b="0"/>
           </a:stretch>
@@ -10721,7 +10722,7 @@
                 <a:ea typeface="微软雅黑"/>
                 <a:cs typeface="微软雅黑"/>
               </a:rPr>
-              <a:t>真实测试证据：7 项官方要求映射用例全部通过</a:t>
+              <a:t>真实测试证据：A3 与讲解视频专项均 8 / 8 通过</a:t>
             </a:r>
           </a:p>
         </p:txBody>
@@ -10917,7 +10918,7 @@
           <p:nvPr/>
         </p:nvPicPr>
         <p:blipFill>
-          <a:blip xmlns:r="http://schemas.openxmlformats.org/officeDocument/2006/relationships" xmlns:a="http://schemas.openxmlformats.org/drawingml/2006/main" r:embed="Rf2fd73cc439b42c8"/>
+          <a:blip xmlns:r="http://schemas.openxmlformats.org/officeDocument/2006/relationships" xmlns:a="http://schemas.openxmlformats.org/drawingml/2006/main" r:embed="R45a6240dfe3c42b4"/>
           <a:stretch xmlns:a="http://schemas.openxmlformats.org/drawingml/2006/main">
             <a:fillRect l="0" t="0" r="0" b="0"/>
           </a:stretch>
@@ -11019,7 +11020,7 @@
                 <a:ea typeface="微软雅黑"/>
                 <a:cs typeface="微软雅黑"/>
               </a:rPr>
-              <a:t>专项验收 7 / 7</a:t>
+              <a:t>A3 专项 8 / 8</a:t>
             </a:r>
           </a:p>
         </p:txBody>
@@ -11111,7 +11112,7 @@
                 <a:ea typeface="微软雅黑"/>
                 <a:cs typeface="微软雅黑"/>
               </a:rPr>
-              <a:t>后端回归 273 passed</a:t>
+              <a:t>视频专项 8 / 8</a:t>
             </a:r>
           </a:p>
         </p:txBody>
@@ -11203,7 +11204,7 @@
                 <a:ea typeface="微软雅黑"/>
                 <a:cs typeface="微软雅黑"/>
               </a:rPr>
-              <a:t>前端 55 tests passed</a:t>
+              <a:t>后端 282 passed</a:t>
             </a:r>
           </a:p>
         </p:txBody>
@@ -11295,7 +11296,7 @@
                 <a:ea typeface="微软雅黑"/>
                 <a:cs typeface="微软雅黑"/>
               </a:rPr>
-              <a:t>失败 / 错误 0 / 0</a:t>
+              <a:t>前端 55 tests passed</a:t>
             </a:r>
           </a:p>
         </p:txBody>
@@ -12883,7 +12884,7 @@
           <p:nvPr/>
         </p:nvPicPr>
         <p:blipFill>
-          <a:blip xmlns:r="http://schemas.openxmlformats.org/officeDocument/2006/relationships" xmlns:a="http://schemas.openxmlformats.org/drawingml/2006/main" r:embed="R5a54012f41d94703"/>
+          <a:blip xmlns:r="http://schemas.openxmlformats.org/officeDocument/2006/relationships" xmlns:a="http://schemas.openxmlformats.org/drawingml/2006/main" r:embed="Ra627bfe9f7fc4581"/>
           <a:srcRect xmlns:a="http://schemas.openxmlformats.org/drawingml/2006/main" l="-17" t="11894" r="0" b="0"/>
           <a:stretch xmlns:a="http://schemas.openxmlformats.org/drawingml/2006/main">
             <a:fillRect l="0" t="0" r="0" b="0"/>
@@ -13977,7 +13978,7 @@
           <p:nvPr/>
         </p:nvPicPr>
         <p:blipFill>
-          <a:blip xmlns:r="http://schemas.openxmlformats.org/officeDocument/2006/relationships" xmlns:a="http://schemas.openxmlformats.org/drawingml/2006/main" r:embed="R6d7ab19492744118"/>
+          <a:blip xmlns:r="http://schemas.openxmlformats.org/officeDocument/2006/relationships" xmlns:a="http://schemas.openxmlformats.org/drawingml/2006/main" r:embed="Rdc0bdc0e63244c63"/>
           <a:srcRect xmlns:a="http://schemas.openxmlformats.org/drawingml/2006/main" l="2687" t="0" r="2687" b="0"/>
           <a:stretch xmlns:a="http://schemas.openxmlformats.org/drawingml/2006/main">
             <a:fillRect l="0" t="0" r="0" b="0"/>

</xml_diff>

<commit_message>
feat: add AI course podcast and explainer video demo
</commit_message>
<xml_diff>
--- a/to_be_submitted_docs/答辩.pptx
+++ b/to_be_submitted_docs/答辩.pptx
@@ -2,30 +2,31 @@
 <file path=ppt/presentation.xml><?xml version="1.0" encoding="utf-8"?>
 <p:presentation xmlns:p="http://schemas.openxmlformats.org/presentationml/2006/main">
   <p:sldMasterIdLst>
-    <p:sldMasterId xmlns:r="http://schemas.openxmlformats.org/officeDocument/2006/relationships" id="2147483648" r:id="R31539d53038e4e53"/>
+    <p:sldMasterId xmlns:r="http://schemas.openxmlformats.org/officeDocument/2006/relationships" id="2147483648" r:id="Rbead282e73084e5b"/>
   </p:sldMasterIdLst>
   <p:notesMasterIdLst>
-    <p:notesMasterId xmlns:r="http://schemas.openxmlformats.org/officeDocument/2006/relationships" r:id="R7e749ccb906a4321"/>
+    <p:notesMasterId xmlns:r="http://schemas.openxmlformats.org/officeDocument/2006/relationships" r:id="R5500693edfbb4e93"/>
   </p:notesMasterIdLst>
   <p:sldIdLst>
-    <p:sldId xmlns:r="http://schemas.openxmlformats.org/officeDocument/2006/relationships" id="256" r:id="R97b14a74f95a4c5b"/>
-    <p:sldId xmlns:r="http://schemas.openxmlformats.org/officeDocument/2006/relationships" id="257" r:id="R11f0fa14c9d04b27"/>
-    <p:sldId xmlns:r="http://schemas.openxmlformats.org/officeDocument/2006/relationships" id="258" r:id="Rf8334187efe34f71"/>
-    <p:sldId xmlns:r="http://schemas.openxmlformats.org/officeDocument/2006/relationships" id="259" r:id="Ree9da69487a846d8"/>
-    <p:sldId xmlns:r="http://schemas.openxmlformats.org/officeDocument/2006/relationships" id="260" r:id="R93d63278fa994ee4"/>
-    <p:sldId xmlns:r="http://schemas.openxmlformats.org/officeDocument/2006/relationships" id="261" r:id="Rccaf87845009455c"/>
-    <p:sldId xmlns:r="http://schemas.openxmlformats.org/officeDocument/2006/relationships" id="262" r:id="Rebb1f4bff4cf4904"/>
-    <p:sldId xmlns:r="http://schemas.openxmlformats.org/officeDocument/2006/relationships" id="263" r:id="R1e82a89f71874327"/>
-    <p:sldId xmlns:r="http://schemas.openxmlformats.org/officeDocument/2006/relationships" id="264" r:id="Rd7bcafd0e1fd4e2d"/>
-    <p:sldId xmlns:r="http://schemas.openxmlformats.org/officeDocument/2006/relationships" id="265" r:id="R0876bc9b13bf471b"/>
-    <p:sldId xmlns:r="http://schemas.openxmlformats.org/officeDocument/2006/relationships" id="266" r:id="Re0cc3ada60d540f3"/>
-    <p:sldId xmlns:r="http://schemas.openxmlformats.org/officeDocument/2006/relationships" id="267" r:id="Rdbc3f9c6d1154618"/>
-    <p:sldId xmlns:r="http://schemas.openxmlformats.org/officeDocument/2006/relationships" id="268" r:id="Rad2f39211f4f47d8"/>
-    <p:sldId xmlns:r="http://schemas.openxmlformats.org/officeDocument/2006/relationships" id="269" r:id="Rb673c5afdc2541c4"/>
-    <p:sldId xmlns:r="http://schemas.openxmlformats.org/officeDocument/2006/relationships" id="270" r:id="Rfa8077462380493b"/>
-    <p:sldId xmlns:r="http://schemas.openxmlformats.org/officeDocument/2006/relationships" id="271" r:id="Rdb86c78ead014094"/>
-    <p:sldId xmlns:r="http://schemas.openxmlformats.org/officeDocument/2006/relationships" id="272" r:id="R615f244074104ac9"/>
-    <p:sldId xmlns:r="http://schemas.openxmlformats.org/officeDocument/2006/relationships" id="273" r:id="R118c0b9ae397493a"/>
+    <p:sldId xmlns:r="http://schemas.openxmlformats.org/officeDocument/2006/relationships" id="256" r:id="R351d93a94d7c48fe"/>
+    <p:sldId xmlns:r="http://schemas.openxmlformats.org/officeDocument/2006/relationships" id="257" r:id="R774b437cca5c44b4"/>
+    <p:sldId xmlns:r="http://schemas.openxmlformats.org/officeDocument/2006/relationships" id="258" r:id="Rd935652026cd403c"/>
+    <p:sldId xmlns:r="http://schemas.openxmlformats.org/officeDocument/2006/relationships" id="259" r:id="R8e84e385c99347c0"/>
+    <p:sldId xmlns:r="http://schemas.openxmlformats.org/officeDocument/2006/relationships" id="260" r:id="Rc1d93bbef18a43f5"/>
+    <p:sldId xmlns:r="http://schemas.openxmlformats.org/officeDocument/2006/relationships" id="261" r:id="R257bb9817122418a"/>
+    <p:sldId xmlns:r="http://schemas.openxmlformats.org/officeDocument/2006/relationships" id="262" r:id="R2330655b5f4644b0"/>
+    <p:sldId xmlns:r="http://schemas.openxmlformats.org/officeDocument/2006/relationships" id="263" r:id="R2d4beff667e94219"/>
+    <p:sldId xmlns:r="http://schemas.openxmlformats.org/officeDocument/2006/relationships" id="264" r:id="R826e7c297af64798"/>
+    <p:sldId xmlns:r="http://schemas.openxmlformats.org/officeDocument/2006/relationships" id="265" r:id="Reecfc2b85b9743a5"/>
+    <p:sldId xmlns:r="http://schemas.openxmlformats.org/officeDocument/2006/relationships" id="266" r:id="Rb11fe65177a64b62"/>
+    <p:sldId xmlns:r="http://schemas.openxmlformats.org/officeDocument/2006/relationships" id="267" r:id="R632c0c3525684f79"/>
+    <p:sldId xmlns:r="http://schemas.openxmlformats.org/officeDocument/2006/relationships" id="268" r:id="R769654d0606e4117"/>
+    <p:sldId xmlns:r="http://schemas.openxmlformats.org/officeDocument/2006/relationships" id="269" r:id="R2ca02688e22e467a"/>
+    <p:sldId xmlns:r="http://schemas.openxmlformats.org/officeDocument/2006/relationships" id="270" r:id="Rdb378d78929c4cd5"/>
+    <p:sldId xmlns:r="http://schemas.openxmlformats.org/officeDocument/2006/relationships" id="271" r:id="Ra76d7a48e19c4669"/>
+    <p:sldId xmlns:r="http://schemas.openxmlformats.org/officeDocument/2006/relationships" id="272" r:id="R10015ee0a0684e94"/>
+    <p:sldId xmlns:r="http://schemas.openxmlformats.org/officeDocument/2006/relationships" id="273" r:id="Raa98d63d0948454a"/>
+    <p:sldId xmlns:r="http://schemas.openxmlformats.org/officeDocument/2006/relationships" id="274" r:id="R2e2e561a3f1a49c4"/>
   </p:sldIdLst>
   <p:sldSz cx="12192000" cy="6858000"/>
   <p:notesSz cx="6858000" cy="9144000"/>
@@ -1174,6 +1175,72 @@
 </p:notes>
 </file>
 
+<file path=ppt/notesSlides/notesSlide19.xml><?xml version="1.0" encoding="utf-8"?>
+<p:notes xmlns:p="http://schemas.openxmlformats.org/presentationml/2006/main">
+  <p:cSld>
+    <p:spTree>
+      <p:nvGrpSpPr>
+        <p:cNvPr id="1" name=""/>
+        <p:cNvGrpSpPr/>
+        <p:nvPr/>
+      </p:nvGrpSpPr>
+      <p:grpSpPr>
+        <a:xfrm xmlns:a="http://schemas.openxmlformats.org/drawingml/2006/main"/>
+      </p:grpSpPr>
+      <p:sp>
+        <p:nvSpPr>
+          <p:cNvPr id="2" name="Slide Image Placeholder 1"/>
+          <p:cNvSpPr>
+            <a:spLocks xmlns:a="http://schemas.openxmlformats.org/drawingml/2006/main" noGrp="1"/>
+          </p:cNvSpPr>
+          <p:nvPr>
+            <p:ph type="sldImg" idx="0"/>
+          </p:nvPr>
+        </p:nvSpPr>
+        <p:spPr/>
+      </p:sp>
+      <p:sp>
+        <p:nvSpPr>
+          <p:cNvPr id="3" name="Notes Placeholder 2"/>
+          <p:cNvSpPr>
+            <a:spLocks xmlns:a="http://schemas.openxmlformats.org/drawingml/2006/main" noGrp="1"/>
+          </p:cNvSpPr>
+          <p:nvPr>
+            <p:ph type="body" idx="1"/>
+          </p:nvPr>
+        </p:nvSpPr>
+        <p:spPr/>
+        <p:txBody>
+          <a:bodyPr xmlns:a="http://schemas.openxmlformats.org/drawingml/2006/main"/>
+          <a:lstStyle xmlns:a="http://schemas.openxmlformats.org/drawingml/2006/main"/>
+          <a:p xmlns:a="http://schemas.openxmlformats.org/drawingml/2006/main"/>
+        </p:txBody>
+      </p:sp>
+      <p:sp>
+        <p:nvSpPr>
+          <p:cNvPr id="4" name="Slide Number Placeholder 3"/>
+          <p:cNvSpPr>
+            <a:spLocks xmlns:a="http://schemas.openxmlformats.org/drawingml/2006/main" noGrp="1"/>
+          </p:cNvSpPr>
+          <p:nvPr>
+            <p:ph type="sldNum" idx="5"/>
+          </p:nvPr>
+        </p:nvSpPr>
+        <p:spPr/>
+        <p:txBody>
+          <a:bodyPr xmlns:a="http://schemas.openxmlformats.org/drawingml/2006/main"/>
+          <a:lstStyle xmlns:a="http://schemas.openxmlformats.org/drawingml/2006/main"/>
+          <a:p xmlns:a="http://schemas.openxmlformats.org/drawingml/2006/main"/>
+        </p:txBody>
+      </p:sp>
+    </p:spTree>
+  </p:cSld>
+  <p:clrMapOvr>
+    <a:masterClrMapping xmlns:a="http://schemas.openxmlformats.org/drawingml/2006/main"/>
+  </p:clrMapOvr>
+</p:notes>
+</file>
+
 <file path=ppt/notesSlides/notesSlide2.xml><?xml version="1.0" encoding="utf-8"?>
 <p:notes xmlns:p="http://schemas.openxmlformats.org/presentationml/2006/main">
   <p:cSld>
@@ -1740,7 +1807,7 @@
   </p:cSld>
   <p:clrMap bg1="lt1" tx1="dk1" bg2="lt2" tx2="dk2" accent1="accent1" accent2="accent2" accent3="accent3" accent4="accent4" accent5="accent5" accent6="accent6" hlink="hlink" folHlink="folHlink"/>
   <p:sldLayoutIdLst>
-    <p:sldLayoutId xmlns:r="http://schemas.openxmlformats.org/officeDocument/2006/relationships" id="2147483649" r:id="Reff123c7fe6943b5"/>
+    <p:sldLayoutId xmlns:r="http://schemas.openxmlformats.org/officeDocument/2006/relationships" id="2147483649" r:id="R4a6ae329e494416f"/>
   </p:sldLayoutIdLst>
   <p:txStyles>
     <p:titleStyle>
@@ -5836,7 +5903,7 @@
           <p:nvPr/>
         </p:nvPicPr>
         <p:blipFill>
-          <a:blip xmlns:r="http://schemas.openxmlformats.org/officeDocument/2006/relationships" xmlns:a="http://schemas.openxmlformats.org/drawingml/2006/main" r:embed="R630a8291e0e24322"/>
+          <a:blip xmlns:r="http://schemas.openxmlformats.org/officeDocument/2006/relationships" xmlns:a="http://schemas.openxmlformats.org/drawingml/2006/main" r:embed="Rac1515e029e84bdc"/>
           <a:stretch xmlns:a="http://schemas.openxmlformats.org/drawingml/2006/main">
             <a:fillRect l="0" t="0" r="0" b="0"/>
           </a:stretch>
@@ -6743,7 +6810,7 @@
           <p:nvPr/>
         </p:nvPicPr>
         <p:blipFill>
-          <a:blip xmlns:r="http://schemas.openxmlformats.org/officeDocument/2006/relationships" xmlns:a="http://schemas.openxmlformats.org/drawingml/2006/main" r:embed="R6e217e51bca1499d"/>
+          <a:blip xmlns:r="http://schemas.openxmlformats.org/officeDocument/2006/relationships" xmlns:a="http://schemas.openxmlformats.org/drawingml/2006/main" r:embed="R97a84234b564439d"/>
           <a:stretch xmlns:a="http://schemas.openxmlformats.org/drawingml/2006/main">
             <a:fillRect l="0" t="0" r="0" b="0"/>
           </a:stretch>
@@ -7650,7 +7717,7 @@
           <p:nvPr/>
         </p:nvPicPr>
         <p:blipFill>
-          <a:blip xmlns:r="http://schemas.openxmlformats.org/officeDocument/2006/relationships" xmlns:a="http://schemas.openxmlformats.org/drawingml/2006/main" r:embed="R04054776c0394234"/>
+          <a:blip xmlns:r="http://schemas.openxmlformats.org/officeDocument/2006/relationships" xmlns:a="http://schemas.openxmlformats.org/drawingml/2006/main" r:embed="R3dd480141cf3413e"/>
           <a:stretch xmlns:a="http://schemas.openxmlformats.org/drawingml/2006/main">
             <a:fillRect l="0" t="0" r="0" b="0"/>
           </a:stretch>
@@ -8675,7 +8742,7 @@
           <p:nvPr/>
         </p:nvPicPr>
         <p:blipFill>
-          <a:blip xmlns:r="http://schemas.openxmlformats.org/officeDocument/2006/relationships" xmlns:a="http://schemas.openxmlformats.org/drawingml/2006/main" r:embed="Rbe18694227054c7e"/>
+          <a:blip xmlns:r="http://schemas.openxmlformats.org/officeDocument/2006/relationships" xmlns:a="http://schemas.openxmlformats.org/drawingml/2006/main" r:embed="R9aea3796dbeb4922"/>
           <a:stretch xmlns:a="http://schemas.openxmlformats.org/drawingml/2006/main">
             <a:fillRect l="0" t="0" r="0" b="0"/>
           </a:stretch>
@@ -8791,7 +8858,7 @@
           <p:nvPr/>
         </p:nvPicPr>
         <p:blipFill>
-          <a:blip xmlns:r="http://schemas.openxmlformats.org/officeDocument/2006/relationships" xmlns:a="http://schemas.openxmlformats.org/drawingml/2006/main" r:embed="R84059422180048b0"/>
+          <a:blip xmlns:r="http://schemas.openxmlformats.org/officeDocument/2006/relationships" xmlns:a="http://schemas.openxmlformats.org/drawingml/2006/main" r:embed="Rd4d61b87b9514207"/>
           <a:stretch xmlns:a="http://schemas.openxmlformats.org/drawingml/2006/main">
             <a:fillRect l="0" t="0" r="0" b="0"/>
           </a:stretch>
@@ -8907,7 +8974,7 @@
           <p:nvPr/>
         </p:nvPicPr>
         <p:blipFill>
-          <a:blip xmlns:r="http://schemas.openxmlformats.org/officeDocument/2006/relationships" xmlns:a="http://schemas.openxmlformats.org/drawingml/2006/main" r:embed="R45d0b2a0b84e40c9"/>
+          <a:blip xmlns:r="http://schemas.openxmlformats.org/officeDocument/2006/relationships" xmlns:a="http://schemas.openxmlformats.org/drawingml/2006/main" r:embed="R141e5b96d6a84463"/>
           <a:stretch xmlns:a="http://schemas.openxmlformats.org/drawingml/2006/main">
             <a:fillRect l="0" t="0" r="0" b="0"/>
           </a:stretch>
@@ -9023,7 +9090,7 @@
           <p:nvPr/>
         </p:nvPicPr>
         <p:blipFill>
-          <a:blip xmlns:r="http://schemas.openxmlformats.org/officeDocument/2006/relationships" xmlns:a="http://schemas.openxmlformats.org/drawingml/2006/main" r:embed="Rd704390c3cca4eb3"/>
+          <a:blip xmlns:r="http://schemas.openxmlformats.org/officeDocument/2006/relationships" xmlns:a="http://schemas.openxmlformats.org/drawingml/2006/main" r:embed="R66e05a35b6a54277"/>
           <a:stretch xmlns:a="http://schemas.openxmlformats.org/drawingml/2006/main">
             <a:fillRect l="0" t="0" r="0" b="0"/>
           </a:stretch>
@@ -9139,7 +9206,7 @@
           <p:nvPr/>
         </p:nvPicPr>
         <p:blipFill>
-          <a:blip xmlns:r="http://schemas.openxmlformats.org/officeDocument/2006/relationships" xmlns:a="http://schemas.openxmlformats.org/drawingml/2006/main" r:embed="Rf11f1eacb14f413c"/>
+          <a:blip xmlns:r="http://schemas.openxmlformats.org/officeDocument/2006/relationships" xmlns:a="http://schemas.openxmlformats.org/drawingml/2006/main" r:embed="Rd7a19078e50e47fe"/>
           <a:stretch xmlns:a="http://schemas.openxmlformats.org/drawingml/2006/main">
             <a:fillRect l="0" t="0" r="0" b="0"/>
           </a:stretch>
@@ -9255,7 +9322,7 @@
           <p:nvPr/>
         </p:nvPicPr>
         <p:blipFill>
-          <a:blip xmlns:r="http://schemas.openxmlformats.org/officeDocument/2006/relationships" xmlns:a="http://schemas.openxmlformats.org/drawingml/2006/main" r:embed="Raeb684002a7549e9"/>
+          <a:blip xmlns:r="http://schemas.openxmlformats.org/officeDocument/2006/relationships" xmlns:a="http://schemas.openxmlformats.org/drawingml/2006/main" r:embed="Rb19267e38f044578"/>
           <a:stretch xmlns:a="http://schemas.openxmlformats.org/drawingml/2006/main">
             <a:fillRect l="0" t="0" r="0" b="0"/>
           </a:stretch>
@@ -9371,7 +9438,7 @@
           <p:nvPr/>
         </p:nvPicPr>
         <p:blipFill>
-          <a:blip xmlns:r="http://schemas.openxmlformats.org/officeDocument/2006/relationships" xmlns:a="http://schemas.openxmlformats.org/drawingml/2006/main" r:embed="R6465e8a7646141f6"/>
+          <a:blip xmlns:r="http://schemas.openxmlformats.org/officeDocument/2006/relationships" xmlns:a="http://schemas.openxmlformats.org/drawingml/2006/main" r:embed="Rf29dc1ab3c07476b"/>
           <a:stretch xmlns:a="http://schemas.openxmlformats.org/drawingml/2006/main">
             <a:fillRect l="0" t="0" r="0" b="0"/>
           </a:stretch>
@@ -9487,7 +9554,7 @@
           <p:nvPr/>
         </p:nvPicPr>
         <p:blipFill>
-          <a:blip xmlns:r="http://schemas.openxmlformats.org/officeDocument/2006/relationships" xmlns:a="http://schemas.openxmlformats.org/drawingml/2006/main" r:embed="Rd8945b4ee2b545ac"/>
+          <a:blip xmlns:r="http://schemas.openxmlformats.org/officeDocument/2006/relationships" xmlns:a="http://schemas.openxmlformats.org/drawingml/2006/main" r:embed="Rd7aeaa2f77fc4cc4"/>
           <a:srcRect xmlns:a="http://schemas.openxmlformats.org/drawingml/2006/main" l="0" t="1947" r="0" b="1947"/>
           <a:stretch xmlns:a="http://schemas.openxmlformats.org/drawingml/2006/main">
             <a:fillRect l="0" t="0" r="0" b="0"/>
@@ -10204,7 +10271,7 @@
           <p:nvPr/>
         </p:nvPicPr>
         <p:blipFill>
-          <a:blip xmlns:r="http://schemas.openxmlformats.org/officeDocument/2006/relationships" xmlns:a="http://schemas.openxmlformats.org/drawingml/2006/main" r:embed="R9ad65690639242aa"/>
+          <a:blip xmlns:r="http://schemas.openxmlformats.org/officeDocument/2006/relationships" xmlns:a="http://schemas.openxmlformats.org/drawingml/2006/main" r:embed="R4af8f6a6ba7e4549"/>
           <a:stretch xmlns:a="http://schemas.openxmlformats.org/drawingml/2006/main">
             <a:fillRect l="0" t="0" r="0" b="0"/>
           </a:stretch>
@@ -10379,7 +10446,7 @@
           <p:nvPr/>
         </p:nvPicPr>
         <p:blipFill>
-          <a:blip xmlns:r="http://schemas.openxmlformats.org/officeDocument/2006/relationships" xmlns:a="http://schemas.openxmlformats.org/drawingml/2006/main" r:embed="R9c56f0a2c1a14ec5"/>
+          <a:blip xmlns:r="http://schemas.openxmlformats.org/officeDocument/2006/relationships" xmlns:a="http://schemas.openxmlformats.org/drawingml/2006/main" r:embed="Rbc642b7ee75b4964"/>
           <a:stretch xmlns:a="http://schemas.openxmlformats.org/drawingml/2006/main">
             <a:fillRect l="0" t="0" r="0" b="0"/>
           </a:stretch>
@@ -10918,7 +10985,7 @@
           <p:nvPr/>
         </p:nvPicPr>
         <p:blipFill>
-          <a:blip xmlns:r="http://schemas.openxmlformats.org/officeDocument/2006/relationships" xmlns:a="http://schemas.openxmlformats.org/drawingml/2006/main" r:embed="R45a6240dfe3c42b4"/>
+          <a:blip xmlns:r="http://schemas.openxmlformats.org/officeDocument/2006/relationships" xmlns:a="http://schemas.openxmlformats.org/drawingml/2006/main" r:embed="Rbeced551db924707"/>
           <a:stretch xmlns:a="http://schemas.openxmlformats.org/drawingml/2006/main">
             <a:fillRect l="0" t="0" r="0" b="0"/>
           </a:stretch>
@@ -11332,6 +11399,935 @@
       </p:grpSpPr>
       <p:sp>
         <p:nvSpPr>
+          <p:cNvPr id="22" name="矩形 21">
+            <a:extLst xmlns:a="http://schemas.openxmlformats.org/drawingml/2006/main">
+              <a:ext uri="{FF2B5EF4-FFF2-40B4-BE49-F238E27FC236}">
+                <a16:creationId xmlns:a16="http://schemas.microsoft.com/office/drawing/2014/main" id="{74D175E0-D4C5-4E8D-90F8-F137DCD516A0}"/>
+              </a:ext>
+            </a:extLst>
+          </p:cNvPr>
+          <p:cNvSpPr>
+            <a:spLocks xmlns:a="http://schemas.openxmlformats.org/drawingml/2006/main" noGrp="1"/>
+          </p:cNvSpPr>
+          <p:nvPr/>
+        </p:nvSpPr>
+        <p:spPr>
+          <a:xfrm xmlns:a="http://schemas.openxmlformats.org/drawingml/2006/main">
+            <a:off x="0" y="0"/>
+            <a:ext cx="12192000" cy="6858000"/>
+          </a:xfrm>
+          <a:prstGeom xmlns:a="http://schemas.openxmlformats.org/drawingml/2006/main" prst="rect">
+            <a:avLst/>
+          </a:prstGeom>
+          <a:solidFill xmlns:a="http://schemas.openxmlformats.org/drawingml/2006/main">
+            <a:srgbClr val="FBFDFF"/>
+          </a:solidFill>
+          <a:ln xmlns:a="http://schemas.openxmlformats.org/drawingml/2006/main" w="0">
+            <a:noFill/>
+            <a:prstDash val="solid"/>
+          </a:ln>
+        </p:spPr>
+      </p:sp>
+      <p:sp>
+        <p:nvSpPr>
+          <p:cNvPr id="2" name="矩形 1">
+            <a:extLst xmlns:a="http://schemas.openxmlformats.org/drawingml/2006/main">
+              <a:ext uri="{FF2B5EF4-FFF2-40B4-BE49-F238E27FC236}">
+                <a16:creationId xmlns:a16="http://schemas.microsoft.com/office/drawing/2014/main" id="{A70F9C28-8A6D-450B-8C2D-2690E6767CD3}"/>
+              </a:ext>
+            </a:extLst>
+          </p:cNvPr>
+          <p:cNvSpPr>
+            <a:spLocks xmlns:a="http://schemas.openxmlformats.org/drawingml/2006/main" noGrp="1"/>
+          </p:cNvSpPr>
+          <p:nvPr/>
+        </p:nvSpPr>
+        <p:spPr>
+          <a:xfrm xmlns:a="http://schemas.openxmlformats.org/drawingml/2006/main">
+            <a:off x="0" y="0"/>
+            <a:ext cx="12192000" cy="1619250"/>
+          </a:xfrm>
+          <a:prstGeom xmlns:a="http://schemas.openxmlformats.org/drawingml/2006/main" prst="rect">
+            <a:avLst/>
+          </a:prstGeom>
+          <a:solidFill xmlns:a="http://schemas.openxmlformats.org/drawingml/2006/main">
+            <a:srgbClr val="F2F7FF"/>
+          </a:solidFill>
+          <a:ln xmlns:a="http://schemas.openxmlformats.org/drawingml/2006/main" w="0">
+            <a:noFill/>
+            <a:prstDash val="solid"/>
+          </a:ln>
+        </p:spPr>
+      </p:sp>
+      <p:sp>
+        <p:nvSpPr>
+          <p:cNvPr id="3" name="矩形 2">
+            <a:extLst xmlns:a="http://schemas.openxmlformats.org/drawingml/2006/main">
+              <a:ext uri="{FF2B5EF4-FFF2-40B4-BE49-F238E27FC236}">
+                <a16:creationId xmlns:a16="http://schemas.microsoft.com/office/drawing/2014/main" id="{7ACD7CE6-53C3-4989-80B8-41324B2AD51E}"/>
+              </a:ext>
+            </a:extLst>
+          </p:cNvPr>
+          <p:cNvSpPr>
+            <a:spLocks xmlns:a="http://schemas.openxmlformats.org/drawingml/2006/main" noGrp="1"/>
+          </p:cNvSpPr>
+          <p:nvPr/>
+        </p:nvSpPr>
+        <p:spPr>
+          <a:xfrm xmlns:a="http://schemas.openxmlformats.org/drawingml/2006/main">
+            <a:off x="0" y="0"/>
+            <a:ext cx="76200" cy="6858000"/>
+          </a:xfrm>
+          <a:prstGeom xmlns:a="http://schemas.openxmlformats.org/drawingml/2006/main" prst="rect">
+            <a:avLst/>
+          </a:prstGeom>
+          <a:solidFill xmlns:a="http://schemas.openxmlformats.org/drawingml/2006/main">
+            <a:srgbClr val="2563EB"/>
+          </a:solidFill>
+          <a:ln xmlns:a="http://schemas.openxmlformats.org/drawingml/2006/main" w="0">
+            <a:noFill/>
+            <a:prstDash val="solid"/>
+          </a:ln>
+        </p:spPr>
+      </p:sp>
+      <p:sp>
+        <p:nvSpPr>
+          <p:cNvPr id="4" name="矩形 3">
+            <a:extLst xmlns:a="http://schemas.openxmlformats.org/drawingml/2006/main">
+              <a:ext uri="{FF2B5EF4-FFF2-40B4-BE49-F238E27FC236}">
+                <a16:creationId xmlns:a16="http://schemas.microsoft.com/office/drawing/2014/main" id="{24C48E2D-41BE-4D9B-9645-B30B943DD362}"/>
+              </a:ext>
+            </a:extLst>
+          </p:cNvPr>
+          <p:cNvSpPr>
+            <a:spLocks xmlns:a="http://schemas.openxmlformats.org/drawingml/2006/main" noGrp="1"/>
+          </p:cNvSpPr>
+          <p:nvPr/>
+        </p:nvSpPr>
+        <p:spPr>
+          <a:xfrm xmlns:a="http://schemas.openxmlformats.org/drawingml/2006/main">
+            <a:off x="0" y="6191250"/>
+            <a:ext cx="12192000" cy="666750"/>
+          </a:xfrm>
+          <a:prstGeom xmlns:a="http://schemas.openxmlformats.org/drawingml/2006/main" prst="rect">
+            <a:avLst/>
+          </a:prstGeom>
+          <a:solidFill xmlns:a="http://schemas.openxmlformats.org/drawingml/2006/main">
+            <a:srgbClr val="F7FAFD"/>
+          </a:solidFill>
+          <a:ln xmlns:a="http://schemas.openxmlformats.org/drawingml/2006/main" w="0">
+            <a:noFill/>
+            <a:prstDash val="solid"/>
+          </a:ln>
+        </p:spPr>
+      </p:sp>
+      <p:sp>
+        <p:nvSpPr>
+          <p:cNvPr id="5" name="矩形 4">
+            <a:extLst xmlns:a="http://schemas.openxmlformats.org/drawingml/2006/main">
+              <a:ext uri="{FF2B5EF4-FFF2-40B4-BE49-F238E27FC236}">
+                <a16:creationId xmlns:a16="http://schemas.microsoft.com/office/drawing/2014/main" id="{C8ECBD5E-C4B9-41D6-B4D5-2B2BB7DCC0B9}"/>
+              </a:ext>
+            </a:extLst>
+          </p:cNvPr>
+          <p:cNvSpPr>
+            <a:spLocks xmlns:a="http://schemas.openxmlformats.org/drawingml/2006/main" noGrp="1"/>
+          </p:cNvSpPr>
+          <p:nvPr/>
+        </p:nvSpPr>
+        <p:spPr>
+          <a:xfrm xmlns:a="http://schemas.openxmlformats.org/drawingml/2006/main">
+            <a:off x="9906000" y="400050"/>
+            <a:ext cx="1562100" cy="38100"/>
+          </a:xfrm>
+          <a:prstGeom xmlns:a="http://schemas.openxmlformats.org/drawingml/2006/main" prst="rect">
+            <a:avLst/>
+          </a:prstGeom>
+          <a:solidFill xmlns:a="http://schemas.openxmlformats.org/drawingml/2006/main">
+            <a:srgbClr val="06B6D4"/>
+          </a:solidFill>
+          <a:ln xmlns:a="http://schemas.openxmlformats.org/drawingml/2006/main" w="0">
+            <a:noFill/>
+            <a:prstDash val="solid"/>
+          </a:ln>
+        </p:spPr>
+      </p:sp>
+      <p:sp>
+        <p:nvSpPr>
+          <p:cNvPr id="6" name="矩形 5">
+            <a:extLst xmlns:a="http://schemas.openxmlformats.org/drawingml/2006/main">
+              <a:ext uri="{FF2B5EF4-FFF2-40B4-BE49-F238E27FC236}">
+                <a16:creationId xmlns:a16="http://schemas.microsoft.com/office/drawing/2014/main" id="{10D9F2F3-19C7-4653-A5B1-1E2B0E81FFE4}"/>
+              </a:ext>
+            </a:extLst>
+          </p:cNvPr>
+          <p:cNvSpPr>
+            <a:spLocks xmlns:a="http://schemas.openxmlformats.org/drawingml/2006/main" noGrp="1"/>
+          </p:cNvSpPr>
+          <p:nvPr/>
+        </p:nvSpPr>
+        <p:spPr>
+          <a:xfrm xmlns:a="http://schemas.openxmlformats.org/drawingml/2006/main">
+            <a:off x="10839450" y="495300"/>
+            <a:ext cx="628650" cy="19050"/>
+          </a:xfrm>
+          <a:prstGeom xmlns:a="http://schemas.openxmlformats.org/drawingml/2006/main" prst="rect">
+            <a:avLst/>
+          </a:prstGeom>
+          <a:solidFill xmlns:a="http://schemas.openxmlformats.org/drawingml/2006/main">
+            <a:srgbClr val="2563EB"/>
+          </a:solidFill>
+          <a:ln xmlns:a="http://schemas.openxmlformats.org/drawingml/2006/main" w="0">
+            <a:noFill/>
+            <a:prstDash val="solid"/>
+          </a:ln>
+        </p:spPr>
+      </p:sp>
+      <p:sp>
+        <p:nvSpPr>
+          <p:cNvPr id="7" name="矩形 6">
+            <a:extLst xmlns:a="http://schemas.openxmlformats.org/drawingml/2006/main">
+              <a:ext uri="{FF2B5EF4-FFF2-40B4-BE49-F238E27FC236}">
+                <a16:creationId xmlns:a16="http://schemas.microsoft.com/office/drawing/2014/main" id="{AD9146D5-2605-4C58-A1B1-86D88AA753FE}"/>
+              </a:ext>
+            </a:extLst>
+          </p:cNvPr>
+          <p:cNvSpPr>
+            <a:spLocks xmlns:a="http://schemas.openxmlformats.org/drawingml/2006/main" noGrp="1"/>
+          </p:cNvSpPr>
+          <p:nvPr/>
+        </p:nvSpPr>
+        <p:spPr>
+          <a:xfrm xmlns:a="http://schemas.openxmlformats.org/drawingml/2006/main">
+            <a:off x="495300" y="381000"/>
+            <a:ext cx="4000500" cy="266700"/>
+          </a:xfrm>
+          <a:prstGeom xmlns:a="http://schemas.openxmlformats.org/drawingml/2006/main" prst="rect">
+            <a:avLst/>
+          </a:prstGeom>
+          <a:noFill xmlns:a="http://schemas.openxmlformats.org/drawingml/2006/main"/>
+          <a:ln xmlns:a="http://schemas.openxmlformats.org/drawingml/2006/main" w="0">
+            <a:noFill/>
+            <a:prstDash val="solid"/>
+          </a:ln>
+        </p:spPr>
+        <p:txBody>
+          <a:bodyPr xmlns:a="http://schemas.openxmlformats.org/drawingml/2006/main" anchor="t">
+            <a:normAutofit fontScale="85185"/>
+          </a:bodyPr>
+          <a:lstStyle xmlns:a="http://schemas.openxmlformats.org/drawingml/2006/main"/>
+          <a:p xmlns:a="http://schemas.openxmlformats.org/drawingml/2006/main">
+            <a:pPr algn="l">
+              <a:buNone/>
+              <a:defRPr sz="1350" b="1">
+                <a:solidFill>
+                  <a:srgbClr val="2563EB"/>
+                </a:solidFill>
+                <a:latin typeface="微软雅黑"/>
+                <a:ea typeface="微软雅黑"/>
+                <a:cs typeface="微软雅黑"/>
+              </a:defRPr>
+            </a:pPr>
+            <a:r>
+              <a:rPr sz="1350" b="1">
+                <a:solidFill>
+                  <a:srgbClr val="2563EB"/>
+                </a:solidFill>
+                <a:latin typeface="微软雅黑"/>
+                <a:ea typeface="微软雅黑"/>
+                <a:cs typeface="微软雅黑"/>
+              </a:rPr>
+              <a:t>效果展示</a:t>
+            </a:r>
+          </a:p>
+        </p:txBody>
+      </p:sp>
+      <p:sp>
+        <p:nvSpPr>
+          <p:cNvPr id="8" name="矩形 7">
+            <a:extLst xmlns:a="http://schemas.openxmlformats.org/drawingml/2006/main">
+              <a:ext uri="{FF2B5EF4-FFF2-40B4-BE49-F238E27FC236}">
+                <a16:creationId xmlns:a16="http://schemas.microsoft.com/office/drawing/2014/main" id="{DD33BC0A-2CCD-4B67-A43C-04968216C429}"/>
+              </a:ext>
+            </a:extLst>
+          </p:cNvPr>
+          <p:cNvSpPr>
+            <a:spLocks xmlns:a="http://schemas.openxmlformats.org/drawingml/2006/main" noGrp="1"/>
+          </p:cNvSpPr>
+          <p:nvPr/>
+        </p:nvSpPr>
+        <p:spPr>
+          <a:xfrm xmlns:a="http://schemas.openxmlformats.org/drawingml/2006/main">
+            <a:off x="495300" y="742950"/>
+            <a:ext cx="10668000" cy="742950"/>
+          </a:xfrm>
+          <a:prstGeom xmlns:a="http://schemas.openxmlformats.org/drawingml/2006/main" prst="rect">
+            <a:avLst/>
+          </a:prstGeom>
+          <a:noFill xmlns:a="http://schemas.openxmlformats.org/drawingml/2006/main"/>
+          <a:ln xmlns:a="http://schemas.openxmlformats.org/drawingml/2006/main" w="0">
+            <a:noFill/>
+            <a:prstDash val="solid"/>
+          </a:ln>
+        </p:spPr>
+        <p:txBody>
+          <a:bodyPr xmlns:a="http://schemas.openxmlformats.org/drawingml/2006/main" anchor="t">
+            <a:normAutofit fontScale="100000"/>
+          </a:bodyPr>
+          <a:lstStyle xmlns:a="http://schemas.openxmlformats.org/drawingml/2006/main"/>
+          <a:p xmlns:a="http://schemas.openxmlformats.org/drawingml/2006/main">
+            <a:pPr algn="l">
+              <a:buNone/>
+              <a:defRPr sz="3525" b="1">
+                <a:solidFill>
+                  <a:srgbClr val="111827"/>
+                </a:solidFill>
+                <a:latin typeface="微软雅黑"/>
+                <a:ea typeface="微软雅黑"/>
+                <a:cs typeface="微软雅黑"/>
+              </a:defRPr>
+            </a:pPr>
+            <a:r>
+              <a:rPr sz="3525" b="1">
+                <a:solidFill>
+                  <a:srgbClr val="111827"/>
+                </a:solidFill>
+                <a:latin typeface="微软雅黑"/>
+                <a:ea typeface="微软雅黑"/>
+                <a:cs typeface="微软雅黑"/>
+              </a:rPr>
+              <a:t>真实课程样例：16 分钟播客与讲解视频已生成</a:t>
+            </a:r>
+          </a:p>
+        </p:txBody>
+      </p:sp>
+      <p:sp>
+        <p:nvSpPr>
+          <p:cNvPr id="9" name="矩形 8">
+            <a:extLst xmlns:a="http://schemas.openxmlformats.org/drawingml/2006/main">
+              <a:ext uri="{FF2B5EF4-FFF2-40B4-BE49-F238E27FC236}">
+                <a16:creationId xmlns:a16="http://schemas.microsoft.com/office/drawing/2014/main" id="{0E4124EB-E5ED-4C4B-9173-A1F843D0683E}"/>
+              </a:ext>
+            </a:extLst>
+          </p:cNvPr>
+          <p:cNvSpPr>
+            <a:spLocks xmlns:a="http://schemas.openxmlformats.org/drawingml/2006/main" noGrp="1"/>
+          </p:cNvSpPr>
+          <p:nvPr/>
+        </p:nvSpPr>
+        <p:spPr>
+          <a:xfrm xmlns:a="http://schemas.openxmlformats.org/drawingml/2006/main">
+            <a:off x="495300" y="1581150"/>
+            <a:ext cx="11201400" cy="9525"/>
+          </a:xfrm>
+          <a:prstGeom xmlns:a="http://schemas.openxmlformats.org/drawingml/2006/main" prst="rect">
+            <a:avLst/>
+          </a:prstGeom>
+          <a:solidFill xmlns:a="http://schemas.openxmlformats.org/drawingml/2006/main">
+            <a:srgbClr val="D1D5DB"/>
+          </a:solidFill>
+          <a:ln xmlns:a="http://schemas.openxmlformats.org/drawingml/2006/main" w="0">
+            <a:noFill/>
+            <a:prstDash val="solid"/>
+          </a:ln>
+        </p:spPr>
+      </p:sp>
+      <p:sp>
+        <p:nvSpPr>
+          <p:cNvPr id="10" name="矩形 9">
+            <a:extLst xmlns:a="http://schemas.openxmlformats.org/drawingml/2006/main">
+              <a:ext uri="{FF2B5EF4-FFF2-40B4-BE49-F238E27FC236}">
+                <a16:creationId xmlns:a16="http://schemas.microsoft.com/office/drawing/2014/main" id="{749A64B9-11DF-4900-BB7B-931C199A28DD}"/>
+              </a:ext>
+            </a:extLst>
+          </p:cNvPr>
+          <p:cNvSpPr>
+            <a:spLocks xmlns:a="http://schemas.openxmlformats.org/drawingml/2006/main" noGrp="1"/>
+          </p:cNvSpPr>
+          <p:nvPr/>
+        </p:nvSpPr>
+        <p:spPr>
+          <a:xfrm xmlns:a="http://schemas.openxmlformats.org/drawingml/2006/main">
+            <a:off x="495300" y="6286500"/>
+            <a:ext cx="1714500" cy="228600"/>
+          </a:xfrm>
+          <a:prstGeom xmlns:a="http://schemas.openxmlformats.org/drawingml/2006/main" prst="rect">
+            <a:avLst/>
+          </a:prstGeom>
+          <a:noFill xmlns:a="http://schemas.openxmlformats.org/drawingml/2006/main"/>
+          <a:ln xmlns:a="http://schemas.openxmlformats.org/drawingml/2006/main" w="0">
+            <a:noFill/>
+            <a:prstDash val="solid"/>
+          </a:ln>
+        </p:spPr>
+        <p:txBody>
+          <a:bodyPr xmlns:a="http://schemas.openxmlformats.org/drawingml/2006/main" anchor="t">
+            <a:normAutofit fontScale="80000"/>
+          </a:bodyPr>
+          <a:lstStyle xmlns:a="http://schemas.openxmlformats.org/drawingml/2006/main"/>
+          <a:p xmlns:a="http://schemas.openxmlformats.org/drawingml/2006/main">
+            <a:pPr algn="l">
+              <a:buNone/>
+              <a:defRPr sz="1125" b="0">
+                <a:solidFill>
+                  <a:srgbClr val="6B7280"/>
+                </a:solidFill>
+                <a:latin typeface="微软雅黑"/>
+                <a:ea typeface="微软雅黑"/>
+                <a:cs typeface="微软雅黑"/>
+              </a:defRPr>
+            </a:pPr>
+            <a:r>
+              <a:rPr sz="1125" b="0">
+                <a:solidFill>
+                  <a:srgbClr val="6B7280"/>
+                </a:solidFill>
+                <a:latin typeface="微软雅黑"/>
+                <a:ea typeface="微软雅黑"/>
+                <a:cs typeface="微软雅黑"/>
+              </a:rPr>
+              <a:t>forgenote</a:t>
+            </a:r>
+          </a:p>
+        </p:txBody>
+      </p:sp>
+      <p:sp>
+        <p:nvSpPr>
+          <p:cNvPr id="11" name="矩形 10">
+            <a:extLst xmlns:a="http://schemas.openxmlformats.org/drawingml/2006/main">
+              <a:ext uri="{FF2B5EF4-FFF2-40B4-BE49-F238E27FC236}">
+                <a16:creationId xmlns:a16="http://schemas.microsoft.com/office/drawing/2014/main" id="{45499FDC-40CE-4D35-A924-8B7852E43708}"/>
+              </a:ext>
+            </a:extLst>
+          </p:cNvPr>
+          <p:cNvSpPr>
+            <a:spLocks xmlns:a="http://schemas.openxmlformats.org/drawingml/2006/main" noGrp="1"/>
+          </p:cNvSpPr>
+          <p:nvPr/>
+        </p:nvSpPr>
+        <p:spPr>
+          <a:xfrm xmlns:a="http://schemas.openxmlformats.org/drawingml/2006/main">
+            <a:off x="11239500" y="6286500"/>
+            <a:ext cx="495300" cy="228600"/>
+          </a:xfrm>
+          <a:prstGeom xmlns:a="http://schemas.openxmlformats.org/drawingml/2006/main" prst="rect">
+            <a:avLst/>
+          </a:prstGeom>
+          <a:noFill xmlns:a="http://schemas.openxmlformats.org/drawingml/2006/main"/>
+          <a:ln xmlns:a="http://schemas.openxmlformats.org/drawingml/2006/main" w="0">
+            <a:noFill/>
+            <a:prstDash val="solid"/>
+          </a:ln>
+        </p:spPr>
+        <p:txBody>
+          <a:bodyPr xmlns:a="http://schemas.openxmlformats.org/drawingml/2006/main" anchor="t">
+            <a:normAutofit fontScale="80000"/>
+          </a:bodyPr>
+          <a:lstStyle xmlns:a="http://schemas.openxmlformats.org/drawingml/2006/main"/>
+          <a:p xmlns:a="http://schemas.openxmlformats.org/drawingml/2006/main">
+            <a:pPr algn="r">
+              <a:buNone/>
+              <a:defRPr sz="1125" b="0">
+                <a:solidFill>
+                  <a:srgbClr val="6B7280"/>
+                </a:solidFill>
+                <a:latin typeface="微软雅黑"/>
+                <a:ea typeface="微软雅黑"/>
+                <a:cs typeface="微软雅黑"/>
+              </a:defRPr>
+            </a:pPr>
+            <a:r>
+              <a:rPr sz="1125" b="0">
+                <a:solidFill>
+                  <a:srgbClr val="6B7280"/>
+                </a:solidFill>
+                <a:latin typeface="微软雅黑"/>
+                <a:ea typeface="微软雅黑"/>
+                <a:cs typeface="微软雅黑"/>
+              </a:rPr>
+              <a:t>18</a:t>
+            </a:r>
+          </a:p>
+        </p:txBody>
+      </p:sp>
+      <p:sp>
+        <p:nvSpPr>
+          <p:cNvPr id="12" name="矩形 11">
+            <a:extLst xmlns:a="http://schemas.openxmlformats.org/drawingml/2006/main">
+              <a:ext uri="{FF2B5EF4-FFF2-40B4-BE49-F238E27FC236}">
+                <a16:creationId xmlns:a16="http://schemas.microsoft.com/office/drawing/2014/main" id="{F69CA641-1D69-49A5-BCE1-E25711B25B97}"/>
+              </a:ext>
+            </a:extLst>
+          </p:cNvPr>
+          <p:cNvSpPr>
+            <a:spLocks xmlns:a="http://schemas.openxmlformats.org/drawingml/2006/main" noGrp="1"/>
+          </p:cNvSpPr>
+          <p:nvPr/>
+        </p:nvSpPr>
+        <p:spPr>
+          <a:xfrm xmlns:a="http://schemas.openxmlformats.org/drawingml/2006/main">
+            <a:off x="647700" y="2000250"/>
+            <a:ext cx="6858000" cy="4000500"/>
+          </a:xfrm>
+          <a:prstGeom xmlns:a="http://schemas.openxmlformats.org/drawingml/2006/main" prst="rect">
+            <a:avLst/>
+          </a:prstGeom>
+          <a:solidFill xmlns:a="http://schemas.openxmlformats.org/drawingml/2006/main">
+            <a:srgbClr val="FFFFFF"/>
+          </a:solidFill>
+          <a:ln xmlns:a="http://schemas.openxmlformats.org/drawingml/2006/main" w="9525">
+            <a:solidFill>
+              <a:srgbClr val="D1D5DB"/>
+            </a:solidFill>
+            <a:prstDash val="solid"/>
+          </a:ln>
+        </p:spPr>
+      </p:sp>
+      <p:pic>
+        <p:nvPicPr>
+          <p:cNvPr id="37" name="图片 33"/>
+          <p:cNvPicPr>
+            <a:picLocks xmlns:a="http://schemas.openxmlformats.org/drawingml/2006/main" noChangeAspect="1"/>
+          </p:cNvPicPr>
+          <p:nvPr/>
+        </p:nvPicPr>
+        <p:blipFill>
+          <a:blip xmlns:r="http://schemas.openxmlformats.org/officeDocument/2006/relationships" xmlns:a="http://schemas.openxmlformats.org/drawingml/2006/main" r:embed="R754f1291a42942fe"/>
+          <a:stretch xmlns:a="http://schemas.openxmlformats.org/drawingml/2006/main">
+            <a:fillRect l="0" t="0" r="0" b="0"/>
+          </a:stretch>
+        </p:blipFill>
+        <p:spPr>
+          <a:xfrm xmlns:a="http://schemas.openxmlformats.org/drawingml/2006/main" flipH="0" flipV="0">
+            <a:off x="1136483" y="2057400"/>
+            <a:ext cx="5880434" cy="3886200"/>
+          </a:xfrm>
+          <a:prstGeom xmlns:a="http://schemas.openxmlformats.org/drawingml/2006/main" prst="rect">
+            <a:avLst/>
+          </a:prstGeom>
+        </p:spPr>
+      </p:pic>
+      <p:sp>
+        <p:nvSpPr>
+          <p:cNvPr id="14" name="矩形 13">
+            <a:extLst xmlns:a="http://schemas.openxmlformats.org/drawingml/2006/main">
+              <a:ext uri="{FF2B5EF4-FFF2-40B4-BE49-F238E27FC236}">
+                <a16:creationId xmlns:a16="http://schemas.microsoft.com/office/drawing/2014/main" id="{6394FEC1-CC23-4582-907D-B242E5B0A695}"/>
+              </a:ext>
+            </a:extLst>
+          </p:cNvPr>
+          <p:cNvSpPr>
+            <a:spLocks xmlns:a="http://schemas.openxmlformats.org/drawingml/2006/main" noGrp="1"/>
+          </p:cNvSpPr>
+          <p:nvPr/>
+        </p:nvSpPr>
+        <p:spPr>
+          <a:xfrm xmlns:a="http://schemas.openxmlformats.org/drawingml/2006/main">
+            <a:off x="8096250" y="2247900"/>
+            <a:ext cx="2857500" cy="723900"/>
+          </a:xfrm>
+          <a:prstGeom xmlns:a="http://schemas.openxmlformats.org/drawingml/2006/main" prst="rect">
+            <a:avLst/>
+          </a:prstGeom>
+          <a:solidFill xmlns:a="http://schemas.openxmlformats.org/drawingml/2006/main">
+            <a:srgbClr val="F3F4F6"/>
+          </a:solidFill>
+          <a:ln xmlns:a="http://schemas.openxmlformats.org/drawingml/2006/main" w="9525">
+            <a:solidFill>
+              <a:srgbClr val="D1D5DB"/>
+            </a:solidFill>
+            <a:prstDash val="solid"/>
+          </a:ln>
+        </p:spPr>
+      </p:sp>
+      <p:sp>
+        <p:nvSpPr>
+          <p:cNvPr id="15" name="矩形 14">
+            <a:extLst xmlns:a="http://schemas.openxmlformats.org/drawingml/2006/main">
+              <a:ext uri="{FF2B5EF4-FFF2-40B4-BE49-F238E27FC236}">
+                <a16:creationId xmlns:a16="http://schemas.microsoft.com/office/drawing/2014/main" id="{979CF3DF-EE84-4E13-A93F-74E7EAA144EC}"/>
+              </a:ext>
+            </a:extLst>
+          </p:cNvPr>
+          <p:cNvSpPr>
+            <a:spLocks xmlns:a="http://schemas.openxmlformats.org/drawingml/2006/main" noGrp="1"/>
+          </p:cNvSpPr>
+          <p:nvPr/>
+        </p:nvSpPr>
+        <p:spPr>
+          <a:xfrm xmlns:a="http://schemas.openxmlformats.org/drawingml/2006/main">
+            <a:off x="8324850" y="2419350"/>
+            <a:ext cx="2400300" cy="400050"/>
+          </a:xfrm>
+          <a:prstGeom xmlns:a="http://schemas.openxmlformats.org/drawingml/2006/main" prst="rect">
+            <a:avLst/>
+          </a:prstGeom>
+          <a:noFill xmlns:a="http://schemas.openxmlformats.org/drawingml/2006/main"/>
+          <a:ln xmlns:a="http://schemas.openxmlformats.org/drawingml/2006/main" w="0">
+            <a:noFill/>
+            <a:prstDash val="solid"/>
+          </a:ln>
+        </p:spPr>
+        <p:txBody>
+          <a:bodyPr xmlns:a="http://schemas.openxmlformats.org/drawingml/2006/main" anchor="t">
+            <a:normAutofit fontScale="100000"/>
+          </a:bodyPr>
+          <a:lstStyle xmlns:a="http://schemas.openxmlformats.org/drawingml/2006/main"/>
+          <a:p xmlns:a="http://schemas.openxmlformats.org/drawingml/2006/main">
+            <a:pPr algn="l">
+              <a:buNone/>
+              <a:defRPr sz="1650" b="1">
+                <a:solidFill>
+                  <a:srgbClr val="111827"/>
+                </a:solidFill>
+                <a:latin typeface="微软雅黑"/>
+                <a:ea typeface="微软雅黑"/>
+                <a:cs typeface="微软雅黑"/>
+              </a:defRPr>
+            </a:pPr>
+            <a:r>
+              <a:rPr sz="1650" b="1">
+                <a:solidFill>
+                  <a:srgbClr val="111827"/>
+                </a:solidFill>
+                <a:latin typeface="微软雅黑"/>
+                <a:ea typeface="微软雅黑"/>
+                <a:cs typeface="微软雅黑"/>
+              </a:rPr>
+              <a:t>完整播客 16:30</a:t>
+            </a:r>
+          </a:p>
+        </p:txBody>
+      </p:sp>
+      <p:sp>
+        <p:nvSpPr>
+          <p:cNvPr id="16" name="矩形 15">
+            <a:extLst xmlns:a="http://schemas.openxmlformats.org/drawingml/2006/main">
+              <a:ext uri="{FF2B5EF4-FFF2-40B4-BE49-F238E27FC236}">
+                <a16:creationId xmlns:a16="http://schemas.microsoft.com/office/drawing/2014/main" id="{CDB6B0C4-D0E9-46F0-9BCE-46E80F30A483}"/>
+              </a:ext>
+            </a:extLst>
+          </p:cNvPr>
+          <p:cNvSpPr>
+            <a:spLocks xmlns:a="http://schemas.openxmlformats.org/drawingml/2006/main" noGrp="1"/>
+          </p:cNvSpPr>
+          <p:nvPr/>
+        </p:nvSpPr>
+        <p:spPr>
+          <a:xfrm xmlns:a="http://schemas.openxmlformats.org/drawingml/2006/main">
+            <a:off x="8096250" y="3276600"/>
+            <a:ext cx="2857500" cy="723900"/>
+          </a:xfrm>
+          <a:prstGeom xmlns:a="http://schemas.openxmlformats.org/drawingml/2006/main" prst="rect">
+            <a:avLst/>
+          </a:prstGeom>
+          <a:solidFill xmlns:a="http://schemas.openxmlformats.org/drawingml/2006/main">
+            <a:srgbClr val="F3F4F6"/>
+          </a:solidFill>
+          <a:ln xmlns:a="http://schemas.openxmlformats.org/drawingml/2006/main" w="9525">
+            <a:solidFill>
+              <a:srgbClr val="D1D5DB"/>
+            </a:solidFill>
+            <a:prstDash val="solid"/>
+          </a:ln>
+        </p:spPr>
+      </p:sp>
+      <p:sp>
+        <p:nvSpPr>
+          <p:cNvPr id="17" name="矩形 16">
+            <a:extLst xmlns:a="http://schemas.openxmlformats.org/drawingml/2006/main">
+              <a:ext uri="{FF2B5EF4-FFF2-40B4-BE49-F238E27FC236}">
+                <a16:creationId xmlns:a16="http://schemas.microsoft.com/office/drawing/2014/main" id="{432A1E1B-B45C-4BA1-A9AB-463A0D955D70}"/>
+              </a:ext>
+            </a:extLst>
+          </p:cNvPr>
+          <p:cNvSpPr>
+            <a:spLocks xmlns:a="http://schemas.openxmlformats.org/drawingml/2006/main" noGrp="1"/>
+          </p:cNvSpPr>
+          <p:nvPr/>
+        </p:nvSpPr>
+        <p:spPr>
+          <a:xfrm xmlns:a="http://schemas.openxmlformats.org/drawingml/2006/main">
+            <a:off x="8324850" y="3448050"/>
+            <a:ext cx="2400300" cy="400050"/>
+          </a:xfrm>
+          <a:prstGeom xmlns:a="http://schemas.openxmlformats.org/drawingml/2006/main" prst="rect">
+            <a:avLst/>
+          </a:prstGeom>
+          <a:noFill xmlns:a="http://schemas.openxmlformats.org/drawingml/2006/main"/>
+          <a:ln xmlns:a="http://schemas.openxmlformats.org/drawingml/2006/main" w="0">
+            <a:noFill/>
+            <a:prstDash val="solid"/>
+          </a:ln>
+        </p:spPr>
+        <p:txBody>
+          <a:bodyPr xmlns:a="http://schemas.openxmlformats.org/drawingml/2006/main" anchor="t">
+            <a:normAutofit fontScale="100000"/>
+          </a:bodyPr>
+          <a:lstStyle xmlns:a="http://schemas.openxmlformats.org/drawingml/2006/main"/>
+          <a:p xmlns:a="http://schemas.openxmlformats.org/drawingml/2006/main">
+            <a:pPr algn="l">
+              <a:buNone/>
+              <a:defRPr sz="1650" b="1">
+                <a:solidFill>
+                  <a:srgbClr val="111827"/>
+                </a:solidFill>
+                <a:latin typeface="微软雅黑"/>
+                <a:ea typeface="微软雅黑"/>
+                <a:cs typeface="微软雅黑"/>
+              </a:defRPr>
+            </a:pPr>
+            <a:r>
+              <a:rPr sz="1650" b="1">
+                <a:solidFill>
+                  <a:srgbClr val="111827"/>
+                </a:solidFill>
+                <a:latin typeface="微软雅黑"/>
+                <a:ea typeface="微软雅黑"/>
+                <a:cs typeface="微软雅黑"/>
+              </a:rPr>
+              <a:t>中文讲解 33 段</a:t>
+            </a:r>
+          </a:p>
+        </p:txBody>
+      </p:sp>
+      <p:sp>
+        <p:nvSpPr>
+          <p:cNvPr id="18" name="矩形 17">
+            <a:extLst xmlns:a="http://schemas.openxmlformats.org/drawingml/2006/main">
+              <a:ext uri="{FF2B5EF4-FFF2-40B4-BE49-F238E27FC236}">
+                <a16:creationId xmlns:a16="http://schemas.microsoft.com/office/drawing/2014/main" id="{E2A8A6A8-B8B2-4565-8669-29438E355368}"/>
+              </a:ext>
+            </a:extLst>
+          </p:cNvPr>
+          <p:cNvSpPr>
+            <a:spLocks xmlns:a="http://schemas.openxmlformats.org/drawingml/2006/main" noGrp="1"/>
+          </p:cNvSpPr>
+          <p:nvPr/>
+        </p:nvSpPr>
+        <p:spPr>
+          <a:xfrm xmlns:a="http://schemas.openxmlformats.org/drawingml/2006/main">
+            <a:off x="8096250" y="4305300"/>
+            <a:ext cx="2857500" cy="723900"/>
+          </a:xfrm>
+          <a:prstGeom xmlns:a="http://schemas.openxmlformats.org/drawingml/2006/main" prst="rect">
+            <a:avLst/>
+          </a:prstGeom>
+          <a:solidFill xmlns:a="http://schemas.openxmlformats.org/drawingml/2006/main">
+            <a:srgbClr val="F3F4F6"/>
+          </a:solidFill>
+          <a:ln xmlns:a="http://schemas.openxmlformats.org/drawingml/2006/main" w="9525">
+            <a:solidFill>
+              <a:srgbClr val="D1D5DB"/>
+            </a:solidFill>
+            <a:prstDash val="solid"/>
+          </a:ln>
+        </p:spPr>
+      </p:sp>
+      <p:sp>
+        <p:nvSpPr>
+          <p:cNvPr id="19" name="矩形 18">
+            <a:extLst xmlns:a="http://schemas.openxmlformats.org/drawingml/2006/main">
+              <a:ext uri="{FF2B5EF4-FFF2-40B4-BE49-F238E27FC236}">
+                <a16:creationId xmlns:a16="http://schemas.microsoft.com/office/drawing/2014/main" id="{8A13A0AB-9242-4DA3-8892-23CFBAEA25A5}"/>
+              </a:ext>
+            </a:extLst>
+          </p:cNvPr>
+          <p:cNvSpPr>
+            <a:spLocks xmlns:a="http://schemas.openxmlformats.org/drawingml/2006/main" noGrp="1"/>
+          </p:cNvSpPr>
+          <p:nvPr/>
+        </p:nvSpPr>
+        <p:spPr>
+          <a:xfrm xmlns:a="http://schemas.openxmlformats.org/drawingml/2006/main">
+            <a:off x="8324850" y="4476750"/>
+            <a:ext cx="2400300" cy="400050"/>
+          </a:xfrm>
+          <a:prstGeom xmlns:a="http://schemas.openxmlformats.org/drawingml/2006/main" prst="rect">
+            <a:avLst/>
+          </a:prstGeom>
+          <a:noFill xmlns:a="http://schemas.openxmlformats.org/drawingml/2006/main"/>
+          <a:ln xmlns:a="http://schemas.openxmlformats.org/drawingml/2006/main" w="0">
+            <a:noFill/>
+            <a:prstDash val="solid"/>
+          </a:ln>
+        </p:spPr>
+        <p:txBody>
+          <a:bodyPr xmlns:a="http://schemas.openxmlformats.org/drawingml/2006/main" anchor="t">
+            <a:normAutofit fontScale="100000"/>
+          </a:bodyPr>
+          <a:lstStyle xmlns:a="http://schemas.openxmlformats.org/drawingml/2006/main"/>
+          <a:p xmlns:a="http://schemas.openxmlformats.org/drawingml/2006/main">
+            <a:pPr algn="l">
+              <a:buNone/>
+              <a:defRPr sz="1650" b="1">
+                <a:solidFill>
+                  <a:srgbClr val="111827"/>
+                </a:solidFill>
+                <a:latin typeface="微软雅黑"/>
+                <a:ea typeface="微软雅黑"/>
+                <a:cs typeface="微软雅黑"/>
+              </a:defRPr>
+            </a:pPr>
+            <a:r>
+              <a:rPr sz="1650" b="1">
+                <a:solidFill>
+                  <a:srgbClr val="111827"/>
+                </a:solidFill>
+                <a:latin typeface="微软雅黑"/>
+                <a:ea typeface="微软雅黑"/>
+                <a:cs typeface="微软雅黑"/>
+              </a:rPr>
+              <a:t>关键画面 9 张</a:t>
+            </a:r>
+          </a:p>
+        </p:txBody>
+      </p:sp>
+      <p:sp>
+        <p:nvSpPr>
+          <p:cNvPr id="20" name="矩形 19">
+            <a:extLst xmlns:a="http://schemas.openxmlformats.org/drawingml/2006/main">
+              <a:ext uri="{FF2B5EF4-FFF2-40B4-BE49-F238E27FC236}">
+                <a16:creationId xmlns:a16="http://schemas.microsoft.com/office/drawing/2014/main" id="{E3B3C15A-2A34-40B8-A65D-B438515035B9}"/>
+              </a:ext>
+            </a:extLst>
+          </p:cNvPr>
+          <p:cNvSpPr>
+            <a:spLocks xmlns:a="http://schemas.openxmlformats.org/drawingml/2006/main" noGrp="1"/>
+          </p:cNvSpPr>
+          <p:nvPr/>
+        </p:nvSpPr>
+        <p:spPr>
+          <a:xfrm xmlns:a="http://schemas.openxmlformats.org/drawingml/2006/main">
+            <a:off x="8096250" y="5334000"/>
+            <a:ext cx="2857500" cy="723900"/>
+          </a:xfrm>
+          <a:prstGeom xmlns:a="http://schemas.openxmlformats.org/drawingml/2006/main" prst="rect">
+            <a:avLst/>
+          </a:prstGeom>
+          <a:solidFill xmlns:a="http://schemas.openxmlformats.org/drawingml/2006/main">
+            <a:srgbClr val="F3F4F6"/>
+          </a:solidFill>
+          <a:ln xmlns:a="http://schemas.openxmlformats.org/drawingml/2006/main" w="9525">
+            <a:solidFill>
+              <a:srgbClr val="D1D5DB"/>
+            </a:solidFill>
+            <a:prstDash val="solid"/>
+          </a:ln>
+        </p:spPr>
+      </p:sp>
+      <p:sp>
+        <p:nvSpPr>
+          <p:cNvPr id="21" name="矩形 20">
+            <a:extLst xmlns:a="http://schemas.openxmlformats.org/drawingml/2006/main">
+              <a:ext uri="{FF2B5EF4-FFF2-40B4-BE49-F238E27FC236}">
+                <a16:creationId xmlns:a16="http://schemas.microsoft.com/office/drawing/2014/main" id="{F55E373D-BD27-4752-BC11-A981BC0B8E64}"/>
+              </a:ext>
+            </a:extLst>
+          </p:cNvPr>
+          <p:cNvSpPr>
+            <a:spLocks xmlns:a="http://schemas.openxmlformats.org/drawingml/2006/main" noGrp="1"/>
+          </p:cNvSpPr>
+          <p:nvPr/>
+        </p:nvSpPr>
+        <p:spPr>
+          <a:xfrm xmlns:a="http://schemas.openxmlformats.org/drawingml/2006/main">
+            <a:off x="8324850" y="5505450"/>
+            <a:ext cx="2400300" cy="400050"/>
+          </a:xfrm>
+          <a:prstGeom xmlns:a="http://schemas.openxmlformats.org/drawingml/2006/main" prst="rect">
+            <a:avLst/>
+          </a:prstGeom>
+          <a:noFill xmlns:a="http://schemas.openxmlformats.org/drawingml/2006/main"/>
+          <a:ln xmlns:a="http://schemas.openxmlformats.org/drawingml/2006/main" w="0">
+            <a:noFill/>
+            <a:prstDash val="solid"/>
+          </a:ln>
+        </p:spPr>
+        <p:txBody>
+          <a:bodyPr xmlns:a="http://schemas.openxmlformats.org/drawingml/2006/main" anchor="t">
+            <a:normAutofit fontScale="100000"/>
+          </a:bodyPr>
+          <a:lstStyle xmlns:a="http://schemas.openxmlformats.org/drawingml/2006/main"/>
+          <a:p xmlns:a="http://schemas.openxmlformats.org/drawingml/2006/main">
+            <a:pPr algn="l">
+              <a:buNone/>
+              <a:defRPr sz="1650" b="1">
+                <a:solidFill>
+                  <a:srgbClr val="111827"/>
+                </a:solidFill>
+                <a:latin typeface="微软雅黑"/>
+                <a:ea typeface="微软雅黑"/>
+                <a:cs typeface="微软雅黑"/>
+              </a:defRPr>
+            </a:pPr>
+            <a:r>
+              <a:rPr sz="1650" b="1">
+                <a:solidFill>
+                  <a:srgbClr val="111827"/>
+                </a:solidFill>
+                <a:latin typeface="微软雅黑"/>
+                <a:ea typeface="微软雅黑"/>
+                <a:cs typeface="微软雅黑"/>
+              </a:rPr>
+              <a:t>视频 1280 × 720</a:t>
+            </a:r>
+          </a:p>
+        </p:txBody>
+      </p:sp>
+      <p:pic>
+        <p:nvPicPr>
+          <p:cNvPr id="46" name=""/>
+          <p:cNvPicPr>
+            <a:picLocks xmlns:a="http://schemas.openxmlformats.org/drawingml/2006/main" noChangeAspect="1"/>
+          </p:cNvPicPr>
+          <p:nvPr/>
+        </p:nvPicPr>
+        <p:blipFill>
+          <a:blip xmlns:r="http://schemas.openxmlformats.org/officeDocument/2006/relationships" xmlns:a="http://schemas.openxmlformats.org/drawingml/2006/main" r:embed="R557a5b56a6884a4d"/>
+          <a:stretch xmlns:a="http://schemas.openxmlformats.org/drawingml/2006/main"/>
+        </p:blipFill>
+        <p:spPr>
+          <a:xfrm xmlns:a="http://schemas.openxmlformats.org/drawingml/2006/main" flipH="0" flipV="0">
+            <a:off x="1136483" y="2057400"/>
+            <a:ext cx="5880434" cy="3886200"/>
+          </a:xfrm>
+          <a:prstGeom xmlns:a="http://schemas.openxmlformats.org/drawingml/2006/main" prst="rect">
+            <a:avLst/>
+          </a:prstGeom>
+        </p:spPr>
+      </p:pic>
+    </p:spTree>
+    <p:extLst>
+      <p:ext uri="{BB962C8B-B14F-4D97-AF65-F5344CB8AC3E}">
+        <p14:creationId xmlns:p14="http://schemas.microsoft.com/office/powerpoint/2010/main" val="1946649072"/>
+      </p:ext>
+    </p:extLst>
+  </p:cSld>
+</p:sld>
+</file>
+
+<file path=ppt/slides/slide19.xml><?xml version="1.0" encoding="utf-8"?>
+<p:sld xmlns:p="http://schemas.openxmlformats.org/presentationml/2006/main">
+  <p:cSld>
+    <p:bg>
+      <p:bgPr>
+        <a:solidFill xmlns:a="http://schemas.openxmlformats.org/drawingml/2006/main">
+          <a:srgbClr val="FBFDFF"/>
+        </a:solidFill>
+      </p:bgPr>
+    </p:bg>
+    <p:spTree>
+      <p:nvGrpSpPr>
+        <p:cNvPr id="1" name=""/>
+        <p:cNvGrpSpPr/>
+        <p:nvPr/>
+      </p:nvGrpSpPr>
+      <p:grpSpPr>
+        <a:xfrm xmlns:a="http://schemas.openxmlformats.org/drawingml/2006/main"/>
+      </p:grpSpPr>
+      <p:sp>
+        <p:nvSpPr>
           <p:cNvPr id="12" name="矩形 11">
             <a:extLst xmlns:a="http://schemas.openxmlformats.org/drawingml/2006/main">
               <a:ext uri="{FF2B5EF4-FFF2-40B4-BE49-F238E27FC236}">
@@ -11806,7 +12802,7 @@
                 <a:ea typeface="微软雅黑"/>
                 <a:cs typeface="微软雅黑"/>
               </a:rPr>
-              <a:t>18</a:t>
+              <a:t>19</a:t>
             </a:r>
           </a:p>
         </p:txBody>
@@ -12884,7 +13880,7 @@
           <p:nvPr/>
         </p:nvPicPr>
         <p:blipFill>
-          <a:blip xmlns:r="http://schemas.openxmlformats.org/officeDocument/2006/relationships" xmlns:a="http://schemas.openxmlformats.org/drawingml/2006/main" r:embed="Ra627bfe9f7fc4581"/>
+          <a:blip xmlns:r="http://schemas.openxmlformats.org/officeDocument/2006/relationships" xmlns:a="http://schemas.openxmlformats.org/drawingml/2006/main" r:embed="R9146add2682a4c0b"/>
           <a:srcRect xmlns:a="http://schemas.openxmlformats.org/drawingml/2006/main" l="-17" t="11894" r="0" b="0"/>
           <a:stretch xmlns:a="http://schemas.openxmlformats.org/drawingml/2006/main">
             <a:fillRect l="0" t="0" r="0" b="0"/>
@@ -13978,7 +14974,7 @@
           <p:nvPr/>
         </p:nvPicPr>
         <p:blipFill>
-          <a:blip xmlns:r="http://schemas.openxmlformats.org/officeDocument/2006/relationships" xmlns:a="http://schemas.openxmlformats.org/drawingml/2006/main" r:embed="Rdc0bdc0e63244c63"/>
+          <a:blip xmlns:r="http://schemas.openxmlformats.org/officeDocument/2006/relationships" xmlns:a="http://schemas.openxmlformats.org/drawingml/2006/main" r:embed="R5326ef00959d47bb"/>
           <a:srcRect xmlns:a="http://schemas.openxmlformats.org/drawingml/2006/main" l="2687" t="0" r="2687" b="0"/>
           <a:stretch xmlns:a="http://schemas.openxmlformats.org/drawingml/2006/main">
             <a:fillRect l="0" t="0" r="0" b="0"/>

</xml_diff>

<commit_message>
feat: add subtitled explainer media to submission
</commit_message>
<xml_diff>
--- a/to_be_submitted_docs/答辩.pptx
+++ b/to_be_submitted_docs/答辩.pptx
@@ -2,31 +2,31 @@
 <file path=ppt/presentation.xml><?xml version="1.0" encoding="utf-8"?>
 <p:presentation xmlns:p="http://schemas.openxmlformats.org/presentationml/2006/main">
   <p:sldMasterIdLst>
-    <p:sldMasterId xmlns:r="http://schemas.openxmlformats.org/officeDocument/2006/relationships" id="2147483648" r:id="Rbead282e73084e5b"/>
+    <p:sldMasterId xmlns:r="http://schemas.openxmlformats.org/officeDocument/2006/relationships" id="2147483648" r:id="Rb388b46a508744f3"/>
   </p:sldMasterIdLst>
   <p:notesMasterIdLst>
-    <p:notesMasterId xmlns:r="http://schemas.openxmlformats.org/officeDocument/2006/relationships" r:id="R5500693edfbb4e93"/>
+    <p:notesMasterId xmlns:r="http://schemas.openxmlformats.org/officeDocument/2006/relationships" r:id="R86466bd1e2ac4f22"/>
   </p:notesMasterIdLst>
   <p:sldIdLst>
-    <p:sldId xmlns:r="http://schemas.openxmlformats.org/officeDocument/2006/relationships" id="256" r:id="R351d93a94d7c48fe"/>
-    <p:sldId xmlns:r="http://schemas.openxmlformats.org/officeDocument/2006/relationships" id="257" r:id="R774b437cca5c44b4"/>
-    <p:sldId xmlns:r="http://schemas.openxmlformats.org/officeDocument/2006/relationships" id="258" r:id="Rd935652026cd403c"/>
-    <p:sldId xmlns:r="http://schemas.openxmlformats.org/officeDocument/2006/relationships" id="259" r:id="R8e84e385c99347c0"/>
-    <p:sldId xmlns:r="http://schemas.openxmlformats.org/officeDocument/2006/relationships" id="260" r:id="Rc1d93bbef18a43f5"/>
-    <p:sldId xmlns:r="http://schemas.openxmlformats.org/officeDocument/2006/relationships" id="261" r:id="R257bb9817122418a"/>
-    <p:sldId xmlns:r="http://schemas.openxmlformats.org/officeDocument/2006/relationships" id="262" r:id="R2330655b5f4644b0"/>
-    <p:sldId xmlns:r="http://schemas.openxmlformats.org/officeDocument/2006/relationships" id="263" r:id="R2d4beff667e94219"/>
-    <p:sldId xmlns:r="http://schemas.openxmlformats.org/officeDocument/2006/relationships" id="264" r:id="R826e7c297af64798"/>
-    <p:sldId xmlns:r="http://schemas.openxmlformats.org/officeDocument/2006/relationships" id="265" r:id="Reecfc2b85b9743a5"/>
-    <p:sldId xmlns:r="http://schemas.openxmlformats.org/officeDocument/2006/relationships" id="266" r:id="Rb11fe65177a64b62"/>
-    <p:sldId xmlns:r="http://schemas.openxmlformats.org/officeDocument/2006/relationships" id="267" r:id="R632c0c3525684f79"/>
-    <p:sldId xmlns:r="http://schemas.openxmlformats.org/officeDocument/2006/relationships" id="268" r:id="R769654d0606e4117"/>
-    <p:sldId xmlns:r="http://schemas.openxmlformats.org/officeDocument/2006/relationships" id="269" r:id="R2ca02688e22e467a"/>
-    <p:sldId xmlns:r="http://schemas.openxmlformats.org/officeDocument/2006/relationships" id="270" r:id="Rdb378d78929c4cd5"/>
-    <p:sldId xmlns:r="http://schemas.openxmlformats.org/officeDocument/2006/relationships" id="271" r:id="Ra76d7a48e19c4669"/>
-    <p:sldId xmlns:r="http://schemas.openxmlformats.org/officeDocument/2006/relationships" id="272" r:id="R10015ee0a0684e94"/>
-    <p:sldId xmlns:r="http://schemas.openxmlformats.org/officeDocument/2006/relationships" id="273" r:id="Raa98d63d0948454a"/>
-    <p:sldId xmlns:r="http://schemas.openxmlformats.org/officeDocument/2006/relationships" id="274" r:id="R2e2e561a3f1a49c4"/>
+    <p:sldId xmlns:r="http://schemas.openxmlformats.org/officeDocument/2006/relationships" id="256" r:id="R7919f64442fa4944"/>
+    <p:sldId xmlns:r="http://schemas.openxmlformats.org/officeDocument/2006/relationships" id="257" r:id="R3397121b41b246af"/>
+    <p:sldId xmlns:r="http://schemas.openxmlformats.org/officeDocument/2006/relationships" id="258" r:id="R9355bc0de22c4d2a"/>
+    <p:sldId xmlns:r="http://schemas.openxmlformats.org/officeDocument/2006/relationships" id="259" r:id="Rca68e165ab3c4fd5"/>
+    <p:sldId xmlns:r="http://schemas.openxmlformats.org/officeDocument/2006/relationships" id="260" r:id="R322bcb32f79e431d"/>
+    <p:sldId xmlns:r="http://schemas.openxmlformats.org/officeDocument/2006/relationships" id="261" r:id="Racd2bd5255b04bfe"/>
+    <p:sldId xmlns:r="http://schemas.openxmlformats.org/officeDocument/2006/relationships" id="262" r:id="R83c070b848904746"/>
+    <p:sldId xmlns:r="http://schemas.openxmlformats.org/officeDocument/2006/relationships" id="263" r:id="R8db2f7706a114a93"/>
+    <p:sldId xmlns:r="http://schemas.openxmlformats.org/officeDocument/2006/relationships" id="264" r:id="R45276be5f4ab43e2"/>
+    <p:sldId xmlns:r="http://schemas.openxmlformats.org/officeDocument/2006/relationships" id="265" r:id="R5dfbf4a19720439b"/>
+    <p:sldId xmlns:r="http://schemas.openxmlformats.org/officeDocument/2006/relationships" id="266" r:id="R52646c2240814cca"/>
+    <p:sldId xmlns:r="http://schemas.openxmlformats.org/officeDocument/2006/relationships" id="267" r:id="R97150a881cc84692"/>
+    <p:sldId xmlns:r="http://schemas.openxmlformats.org/officeDocument/2006/relationships" id="268" r:id="R83186d34d6784af7"/>
+    <p:sldId xmlns:r="http://schemas.openxmlformats.org/officeDocument/2006/relationships" id="269" r:id="Ra137b74eac7d497c"/>
+    <p:sldId xmlns:r="http://schemas.openxmlformats.org/officeDocument/2006/relationships" id="270" r:id="Rba37b6b685d24779"/>
+    <p:sldId xmlns:r="http://schemas.openxmlformats.org/officeDocument/2006/relationships" id="271" r:id="Rac1b968d8b5548ae"/>
+    <p:sldId xmlns:r="http://schemas.openxmlformats.org/officeDocument/2006/relationships" id="272" r:id="R3b26c45f7a6a4d89"/>
+    <p:sldId xmlns:r="http://schemas.openxmlformats.org/officeDocument/2006/relationships" id="273" r:id="Rb9223bde70004bc3"/>
+    <p:sldId xmlns:r="http://schemas.openxmlformats.org/officeDocument/2006/relationships" id="274" r:id="R17e9cd72a5d44666"/>
   </p:sldIdLst>
   <p:sldSz cx="12192000" cy="6858000"/>
   <p:notesSz cx="6858000" cy="9144000"/>
@@ -1807,7 +1807,7 @@
   </p:cSld>
   <p:clrMap bg1="lt1" tx1="dk1" bg2="lt2" tx2="dk2" accent1="accent1" accent2="accent2" accent3="accent3" accent4="accent4" accent5="accent5" accent6="accent6" hlink="hlink" folHlink="folHlink"/>
   <p:sldLayoutIdLst>
-    <p:sldLayoutId xmlns:r="http://schemas.openxmlformats.org/officeDocument/2006/relationships" id="2147483649" r:id="R4a6ae329e494416f"/>
+    <p:sldLayoutId xmlns:r="http://schemas.openxmlformats.org/officeDocument/2006/relationships" id="2147483649" r:id="R8f9213db2d344d1b"/>
   </p:sldLayoutIdLst>
   <p:txStyles>
     <p:titleStyle>
@@ -2535,7 +2535,7 @@
         </p:spPr>
         <p:txBody>
           <a:bodyPr xmlns:a="http://schemas.openxmlformats.org/drawingml/2006/main" anchor="t">
-            <a:normAutofit fontScale="83740"/>
+            <a:normAutofit fontScale="91240" lnSpcReduction="10000"/>
           </a:bodyPr>
           <a:lstStyle xmlns:a="http://schemas.openxmlformats.org/drawingml/2006/main"/>
           <a:p xmlns:a="http://schemas.openxmlformats.org/drawingml/2006/main">
@@ -2559,7 +2559,18 @@
                 <a:ea typeface="微软雅黑"/>
                 <a:cs typeface="微软雅黑"/>
               </a:rPr>
-              <a:t>forgenote</a:t>
+              <a:t>F</a:t>
+            </a:r>
+            <a:r>
+              <a:rPr sz="6150" b="1">
+                <a:solidFill>
+                  <a:srgbClr val="111827"/>
+                </a:solidFill>
+                <a:latin typeface="微软雅黑"/>
+                <a:ea typeface="微软雅黑"/>
+                <a:cs typeface="微软雅黑"/>
+              </a:rPr>
+              <a:t>orgenote</a:t>
             </a:r>
           </a:p>
         </p:txBody>
@@ -3071,7 +3082,7 @@
                 <a:ea typeface="微软雅黑"/>
                 <a:cs typeface="微软雅黑"/>
               </a:rPr>
-              <a:t>forgenote</a:t>
+              <a:t>Forgenote</a:t>
             </a:r>
           </a:p>
         </p:txBody>
@@ -3380,7 +3391,7 @@
         </p:spPr>
         <p:txBody>
           <a:bodyPr xmlns:a="http://schemas.openxmlformats.org/drawingml/2006/main" anchor="t">
-            <a:normAutofit fontScale="100000"/>
+            <a:normAutofit/>
           </a:bodyPr>
           <a:lstStyle xmlns:a="http://schemas.openxmlformats.org/drawingml/2006/main"/>
           <a:p xmlns:a="http://schemas.openxmlformats.org/drawingml/2006/main">
@@ -3494,7 +3505,7 @@
                 <a:ea typeface="微软雅黑"/>
                 <a:cs typeface="微软雅黑"/>
               </a:rPr>
-              <a:t>forgenote</a:t>
+              <a:t>Forgenote</a:t>
             </a:r>
           </a:p>
         </p:txBody>
@@ -4754,7 +4765,7 @@
         </p:spPr>
         <p:txBody>
           <a:bodyPr xmlns:a="http://schemas.openxmlformats.org/drawingml/2006/main" anchor="t">
-            <a:normAutofit fontScale="100000"/>
+            <a:normAutofit/>
           </a:bodyPr>
           <a:lstStyle xmlns:a="http://schemas.openxmlformats.org/drawingml/2006/main"/>
           <a:p xmlns:a="http://schemas.openxmlformats.org/drawingml/2006/main">
@@ -4868,7 +4879,7 @@
                 <a:ea typeface="微软雅黑"/>
                 <a:cs typeface="微软雅黑"/>
               </a:rPr>
-              <a:t>forgenote</a:t>
+              <a:t>Forgenote</a:t>
             </a:r>
           </a:p>
         </p:txBody>
@@ -5052,7 +5063,7 @@
         </p:spPr>
         <p:txBody>
           <a:bodyPr xmlns:a="http://schemas.openxmlformats.org/drawingml/2006/main" anchor="t">
-            <a:normAutofit fontScale="100000"/>
+            <a:normAutofit/>
           </a:bodyPr>
           <a:lstStyle xmlns:a="http://schemas.openxmlformats.org/drawingml/2006/main"/>
           <a:p xmlns:a="http://schemas.openxmlformats.org/drawingml/2006/main">
@@ -5201,7 +5212,7 @@
         </p:spPr>
         <p:txBody>
           <a:bodyPr xmlns:a="http://schemas.openxmlformats.org/drawingml/2006/main" anchor="t">
-            <a:normAutofit fontScale="100000"/>
+            <a:normAutofit/>
           </a:bodyPr>
           <a:lstStyle xmlns:a="http://schemas.openxmlformats.org/drawingml/2006/main"/>
           <a:p xmlns:a="http://schemas.openxmlformats.org/drawingml/2006/main">
@@ -5374,7 +5385,7 @@
                 <a:ea typeface="微软雅黑"/>
                 <a:cs typeface="微软雅黑"/>
               </a:rPr>
-              <a:t>脚本同步给出视觉提示；图片按 TTS 时间点由 FFmpeg 合成 MP4。</a:t>
+              <a:t>脚本同步给出视觉提示；图片与中文字幕按 TTS 时间点由 FFmpeg 合成 MP4。</a:t>
             </a:r>
           </a:p>
         </p:txBody>
@@ -5797,7 +5808,7 @@
                 <a:ea typeface="微软雅黑"/>
                 <a:cs typeface="微软雅黑"/>
               </a:rPr>
-              <a:t>forgenote</a:t>
+              <a:t>Forgenote</a:t>
             </a:r>
           </a:p>
         </p:txBody>
@@ -5903,7 +5914,7 @@
           <p:nvPr/>
         </p:nvPicPr>
         <p:blipFill>
-          <a:blip xmlns:r="http://schemas.openxmlformats.org/officeDocument/2006/relationships" xmlns:a="http://schemas.openxmlformats.org/drawingml/2006/main" r:embed="Rac1515e029e84bdc"/>
+          <a:blip xmlns:r="http://schemas.openxmlformats.org/officeDocument/2006/relationships" xmlns:a="http://schemas.openxmlformats.org/drawingml/2006/main" r:embed="R5d503eb46c274d06"/>
           <a:stretch xmlns:a="http://schemas.openxmlformats.org/drawingml/2006/main">
             <a:fillRect l="0" t="0" r="0" b="0"/>
           </a:stretch>
@@ -6704,7 +6715,7 @@
                 <a:ea typeface="微软雅黑"/>
                 <a:cs typeface="微软雅黑"/>
               </a:rPr>
-              <a:t>forgenote</a:t>
+              <a:t>Forgenote</a:t>
             </a:r>
           </a:p>
         </p:txBody>
@@ -6810,7 +6821,7 @@
           <p:nvPr/>
         </p:nvPicPr>
         <p:blipFill>
-          <a:blip xmlns:r="http://schemas.openxmlformats.org/officeDocument/2006/relationships" xmlns:a="http://schemas.openxmlformats.org/drawingml/2006/main" r:embed="R97a84234b564439d"/>
+          <a:blip xmlns:r="http://schemas.openxmlformats.org/officeDocument/2006/relationships" xmlns:a="http://schemas.openxmlformats.org/drawingml/2006/main" r:embed="R5b2b9b2033f24913"/>
           <a:stretch xmlns:a="http://schemas.openxmlformats.org/drawingml/2006/main">
             <a:fillRect l="0" t="0" r="0" b="0"/>
           </a:stretch>
@@ -7611,7 +7622,7 @@
                 <a:ea typeface="微软雅黑"/>
                 <a:cs typeface="微软雅黑"/>
               </a:rPr>
-              <a:t>forgenote</a:t>
+              <a:t>Forgenote</a:t>
             </a:r>
           </a:p>
         </p:txBody>
@@ -7717,7 +7728,7 @@
           <p:nvPr/>
         </p:nvPicPr>
         <p:blipFill>
-          <a:blip xmlns:r="http://schemas.openxmlformats.org/officeDocument/2006/relationships" xmlns:a="http://schemas.openxmlformats.org/drawingml/2006/main" r:embed="R3dd480141cf3413e"/>
+          <a:blip xmlns:r="http://schemas.openxmlformats.org/officeDocument/2006/relationships" xmlns:a="http://schemas.openxmlformats.org/drawingml/2006/main" r:embed="R60df8ec477c64c91"/>
           <a:stretch xmlns:a="http://schemas.openxmlformats.org/drawingml/2006/main">
             <a:fillRect l="0" t="0" r="0" b="0"/>
           </a:stretch>
@@ -8404,7 +8415,7 @@
         </p:spPr>
         <p:txBody>
           <a:bodyPr xmlns:a="http://schemas.openxmlformats.org/drawingml/2006/main" anchor="t">
-            <a:normAutofit fontScale="100000"/>
+            <a:normAutofit/>
           </a:bodyPr>
           <a:lstStyle xmlns:a="http://schemas.openxmlformats.org/drawingml/2006/main"/>
           <a:p xmlns:a="http://schemas.openxmlformats.org/drawingml/2006/main">
@@ -8449,7 +8460,7 @@
         </p:nvSpPr>
         <p:spPr>
           <a:xfrm xmlns:a="http://schemas.openxmlformats.org/drawingml/2006/main">
-            <a:off x="495300" y="1581150"/>
+            <a:off x="495300" y="1809750"/>
             <a:ext cx="11201400" cy="9525"/>
           </a:xfrm>
           <a:prstGeom xmlns:a="http://schemas.openxmlformats.org/drawingml/2006/main" prst="rect">
@@ -8518,7 +8529,7 @@
                 <a:ea typeface="微软雅黑"/>
                 <a:cs typeface="微软雅黑"/>
               </a:rPr>
-              <a:t>forgenote</a:t>
+              <a:t>Forgenote</a:t>
             </a:r>
           </a:p>
         </p:txBody>
@@ -8636,7 +8647,7 @@
                 <a:ea typeface="微软雅黑"/>
                 <a:cs typeface="微软雅黑"/>
               </a:rPr>
-              <a:t>7 类资产共享画像与来源约束；播客脚本同步规划关键画面，并按真实语音时间轴合成本地 MP4。</a:t>
+              <a:t>7 类资产共享画像与来源约束；播客脚本同步规划关键画面，并按真实语音时间轴合成带中文字幕的本地 MP4。</a:t>
             </a:r>
           </a:p>
         </p:txBody>
@@ -8742,7 +8753,7 @@
           <p:nvPr/>
         </p:nvPicPr>
         <p:blipFill>
-          <a:blip xmlns:r="http://schemas.openxmlformats.org/officeDocument/2006/relationships" xmlns:a="http://schemas.openxmlformats.org/drawingml/2006/main" r:embed="R9aea3796dbeb4922"/>
+          <a:blip xmlns:r="http://schemas.openxmlformats.org/officeDocument/2006/relationships" xmlns:a="http://schemas.openxmlformats.org/drawingml/2006/main" r:embed="R795ba4dc845c45e4"/>
           <a:stretch xmlns:a="http://schemas.openxmlformats.org/drawingml/2006/main">
             <a:fillRect l="0" t="0" r="0" b="0"/>
           </a:stretch>
@@ -8858,7 +8869,7 @@
           <p:nvPr/>
         </p:nvPicPr>
         <p:blipFill>
-          <a:blip xmlns:r="http://schemas.openxmlformats.org/officeDocument/2006/relationships" xmlns:a="http://schemas.openxmlformats.org/drawingml/2006/main" r:embed="Rd4d61b87b9514207"/>
+          <a:blip xmlns:r="http://schemas.openxmlformats.org/officeDocument/2006/relationships" xmlns:a="http://schemas.openxmlformats.org/drawingml/2006/main" r:embed="R181a32e020f24c17"/>
           <a:stretch xmlns:a="http://schemas.openxmlformats.org/drawingml/2006/main">
             <a:fillRect l="0" t="0" r="0" b="0"/>
           </a:stretch>
@@ -8974,7 +8985,7 @@
           <p:nvPr/>
         </p:nvPicPr>
         <p:blipFill>
-          <a:blip xmlns:r="http://schemas.openxmlformats.org/officeDocument/2006/relationships" xmlns:a="http://schemas.openxmlformats.org/drawingml/2006/main" r:embed="R141e5b96d6a84463"/>
+          <a:blip xmlns:r="http://schemas.openxmlformats.org/officeDocument/2006/relationships" xmlns:a="http://schemas.openxmlformats.org/drawingml/2006/main" r:embed="Ra5ed4f1da24a4a67"/>
           <a:stretch xmlns:a="http://schemas.openxmlformats.org/drawingml/2006/main">
             <a:fillRect l="0" t="0" r="0" b="0"/>
           </a:stretch>
@@ -9090,7 +9101,7 @@
           <p:nvPr/>
         </p:nvPicPr>
         <p:blipFill>
-          <a:blip xmlns:r="http://schemas.openxmlformats.org/officeDocument/2006/relationships" xmlns:a="http://schemas.openxmlformats.org/drawingml/2006/main" r:embed="R66e05a35b6a54277"/>
+          <a:blip xmlns:r="http://schemas.openxmlformats.org/officeDocument/2006/relationships" xmlns:a="http://schemas.openxmlformats.org/drawingml/2006/main" r:embed="Ra30edd80607646d0"/>
           <a:stretch xmlns:a="http://schemas.openxmlformats.org/drawingml/2006/main">
             <a:fillRect l="0" t="0" r="0" b="0"/>
           </a:stretch>
@@ -9206,7 +9217,7 @@
           <p:nvPr/>
         </p:nvPicPr>
         <p:blipFill>
-          <a:blip xmlns:r="http://schemas.openxmlformats.org/officeDocument/2006/relationships" xmlns:a="http://schemas.openxmlformats.org/drawingml/2006/main" r:embed="Rd7a19078e50e47fe"/>
+          <a:blip xmlns:r="http://schemas.openxmlformats.org/officeDocument/2006/relationships" xmlns:a="http://schemas.openxmlformats.org/drawingml/2006/main" r:embed="R869674099afb465a"/>
           <a:stretch xmlns:a="http://schemas.openxmlformats.org/drawingml/2006/main">
             <a:fillRect l="0" t="0" r="0" b="0"/>
           </a:stretch>
@@ -9322,7 +9333,7 @@
           <p:nvPr/>
         </p:nvPicPr>
         <p:blipFill>
-          <a:blip xmlns:r="http://schemas.openxmlformats.org/officeDocument/2006/relationships" xmlns:a="http://schemas.openxmlformats.org/drawingml/2006/main" r:embed="Rb19267e38f044578"/>
+          <a:blip xmlns:r="http://schemas.openxmlformats.org/officeDocument/2006/relationships" xmlns:a="http://schemas.openxmlformats.org/drawingml/2006/main" r:embed="Ra73dd5d6892d4767"/>
           <a:stretch xmlns:a="http://schemas.openxmlformats.org/drawingml/2006/main">
             <a:fillRect l="0" t="0" r="0" b="0"/>
           </a:stretch>
@@ -9438,7 +9449,7 @@
           <p:nvPr/>
         </p:nvPicPr>
         <p:blipFill>
-          <a:blip xmlns:r="http://schemas.openxmlformats.org/officeDocument/2006/relationships" xmlns:a="http://schemas.openxmlformats.org/drawingml/2006/main" r:embed="Rf29dc1ab3c07476b"/>
+          <a:blip xmlns:r="http://schemas.openxmlformats.org/officeDocument/2006/relationships" xmlns:a="http://schemas.openxmlformats.org/drawingml/2006/main" r:embed="Re46a4aac0c9f45d7"/>
           <a:stretch xmlns:a="http://schemas.openxmlformats.org/drawingml/2006/main">
             <a:fillRect l="0" t="0" r="0" b="0"/>
           </a:stretch>
@@ -9554,7 +9565,7 @@
           <p:nvPr/>
         </p:nvPicPr>
         <p:blipFill>
-          <a:blip xmlns:r="http://schemas.openxmlformats.org/officeDocument/2006/relationships" xmlns:a="http://schemas.openxmlformats.org/drawingml/2006/main" r:embed="Rd7aeaa2f77fc4cc4"/>
+          <a:blip xmlns:r="http://schemas.openxmlformats.org/officeDocument/2006/relationships" xmlns:a="http://schemas.openxmlformats.org/drawingml/2006/main" r:embed="R821099a28ca94e68"/>
           <a:srcRect xmlns:a="http://schemas.openxmlformats.org/drawingml/2006/main" l="0" t="1947" r="0" b="1947"/>
           <a:stretch xmlns:a="http://schemas.openxmlformats.org/drawingml/2006/main">
             <a:fillRect l="0" t="0" r="0" b="0"/>
@@ -9988,7 +9999,7 @@
                 <a:ea typeface="微软雅黑"/>
                 <a:cs typeface="微软雅黑"/>
               </a:rPr>
-              <a:t>forgenote</a:t>
+              <a:t>Forgenote</a:t>
             </a:r>
           </a:p>
         </p:txBody>
@@ -10271,7 +10282,7 @@
           <p:nvPr/>
         </p:nvPicPr>
         <p:blipFill>
-          <a:blip xmlns:r="http://schemas.openxmlformats.org/officeDocument/2006/relationships" xmlns:a="http://schemas.openxmlformats.org/drawingml/2006/main" r:embed="R4af8f6a6ba7e4549"/>
+          <a:blip xmlns:r="http://schemas.openxmlformats.org/officeDocument/2006/relationships" xmlns:a="http://schemas.openxmlformats.org/drawingml/2006/main" r:embed="R6777f24b4af24954"/>
           <a:stretch xmlns:a="http://schemas.openxmlformats.org/drawingml/2006/main">
             <a:fillRect l="0" t="0" r="0" b="0"/>
           </a:stretch>
@@ -10446,7 +10457,7 @@
           <p:nvPr/>
         </p:nvPicPr>
         <p:blipFill>
-          <a:blip xmlns:r="http://schemas.openxmlformats.org/officeDocument/2006/relationships" xmlns:a="http://schemas.openxmlformats.org/drawingml/2006/main" r:embed="Rbc642b7ee75b4964"/>
+          <a:blip xmlns:r="http://schemas.openxmlformats.org/officeDocument/2006/relationships" xmlns:a="http://schemas.openxmlformats.org/drawingml/2006/main" r:embed="R9e0d6f6aa6bd4ab5"/>
           <a:stretch xmlns:a="http://schemas.openxmlformats.org/drawingml/2006/main">
             <a:fillRect l="0" t="0" r="0" b="0"/>
           </a:stretch>
@@ -10789,7 +10800,7 @@
                 <a:ea typeface="微软雅黑"/>
                 <a:cs typeface="微软雅黑"/>
               </a:rPr>
-              <a:t>真实测试证据：A3 与讲解视频专项均 8 / 8 通过</a:t>
+              <a:t>真实测试证据：A3 8 / 8、讲解视频 11 / 11 通过</a:t>
             </a:r>
           </a:p>
         </p:txBody>
@@ -10879,7 +10890,7 @@
                 <a:ea typeface="微软雅黑"/>
                 <a:cs typeface="微软雅黑"/>
               </a:rPr>
-              <a:t>forgenote</a:t>
+              <a:t>Forgenote</a:t>
             </a:r>
           </a:p>
         </p:txBody>
@@ -10978,20 +10989,20 @@
       </p:sp>
       <p:pic>
         <p:nvPicPr>
-          <p:cNvPr id="36" name="图片 33"/>
+          <p:cNvPr id="37" name="图片 33"/>
           <p:cNvPicPr>
             <a:picLocks xmlns:a="http://schemas.openxmlformats.org/drawingml/2006/main" noChangeAspect="1"/>
           </p:cNvPicPr>
           <p:nvPr/>
         </p:nvPicPr>
         <p:blipFill>
-          <a:blip xmlns:r="http://schemas.openxmlformats.org/officeDocument/2006/relationships" xmlns:a="http://schemas.openxmlformats.org/drawingml/2006/main" r:embed="Rbeced551db924707"/>
+          <a:blip xmlns:r="http://schemas.openxmlformats.org/officeDocument/2006/relationships" xmlns:a="http://schemas.openxmlformats.org/drawingml/2006/main" r:embed="R15a9f3f5fc77493b"/>
           <a:stretch xmlns:a="http://schemas.openxmlformats.org/drawingml/2006/main">
             <a:fillRect l="0" t="0" r="0" b="0"/>
           </a:stretch>
         </p:blipFill>
         <p:spPr>
-          <a:xfrm xmlns:a="http://schemas.openxmlformats.org/drawingml/2006/main" flipH="0" flipV="0">
+          <a:xfrm xmlns:a="http://schemas.openxmlformats.org/drawingml/2006/main">
             <a:off x="1136483" y="2057400"/>
             <a:ext cx="5880434" cy="3886200"/>
           </a:xfrm>
@@ -11063,7 +11074,7 @@
         </p:spPr>
         <p:txBody>
           <a:bodyPr xmlns:a="http://schemas.openxmlformats.org/drawingml/2006/main" anchor="t">
-            <a:normAutofit fontScale="100000"/>
+            <a:normAutofit/>
           </a:bodyPr>
           <a:lstStyle xmlns:a="http://schemas.openxmlformats.org/drawingml/2006/main"/>
           <a:p xmlns:a="http://schemas.openxmlformats.org/drawingml/2006/main">
@@ -11179,7 +11190,7 @@
                 <a:ea typeface="微软雅黑"/>
                 <a:cs typeface="微软雅黑"/>
               </a:rPr>
-              <a:t>视频专项 8 / 8</a:t>
+              <a:t>视频专项 11 / 11</a:t>
             </a:r>
           </a:p>
         </p:txBody>
@@ -11271,7 +11282,7 @@
                 <a:ea typeface="微软雅黑"/>
                 <a:cs typeface="微软雅黑"/>
               </a:rPr>
-              <a:t>后端 282 passed</a:t>
+              <a:t>后端 285 passed</a:t>
             </a:r>
           </a:p>
         </p:txBody>
@@ -11339,7 +11350,7 @@
         </p:spPr>
         <p:txBody>
           <a:bodyPr xmlns:a="http://schemas.openxmlformats.org/drawingml/2006/main" anchor="t">
-            <a:normAutofit fontScale="100000"/>
+            <a:normAutofit/>
           </a:bodyPr>
           <a:lstStyle xmlns:a="http://schemas.openxmlformats.org/drawingml/2006/main"/>
           <a:p xmlns:a="http://schemas.openxmlformats.org/drawingml/2006/main">
@@ -11368,6 +11379,28 @@
           </a:p>
         </p:txBody>
       </p:sp>
+      <p:pic>
+        <p:nvPicPr>
+          <p:cNvPr id="46" name=""/>
+          <p:cNvPicPr>
+            <a:picLocks xmlns:a="http://schemas.openxmlformats.org/drawingml/2006/main" noChangeAspect="1"/>
+          </p:cNvPicPr>
+          <p:nvPr/>
+        </p:nvPicPr>
+        <p:blipFill>
+          <a:blip xmlns:r="http://schemas.openxmlformats.org/officeDocument/2006/relationships" xmlns:a="http://schemas.openxmlformats.org/drawingml/2006/main" r:embed="Rf24075efc44f41ee"/>
+          <a:stretch xmlns:a="http://schemas.openxmlformats.org/drawingml/2006/main"/>
+        </p:blipFill>
+        <p:spPr>
+          <a:xfrm xmlns:a="http://schemas.openxmlformats.org/drawingml/2006/main" flipH="0" flipV="0">
+            <a:off x="1136483" y="2057400"/>
+            <a:ext cx="5880434" cy="3886200"/>
+          </a:xfrm>
+          <a:prstGeom xmlns:a="http://schemas.openxmlformats.org/drawingml/2006/main" prst="rect">
+            <a:avLst/>
+          </a:prstGeom>
+        </p:spPr>
+      </p:pic>
     </p:spTree>
     <p:extLst>
       <p:ext uri="{BB962C8B-B14F-4D97-AF65-F5344CB8AC3E}">
@@ -11427,6 +11460,11 @@
             <a:prstDash val="solid"/>
           </a:ln>
         </p:spPr>
+        <p:txBody>
+          <a:bodyPr xmlns:a="http://schemas.openxmlformats.org/drawingml/2006/main"/>
+          <a:lstStyle xmlns:a="http://schemas.openxmlformats.org/drawingml/2006/main"/>
+          <a:p xmlns:a="http://schemas.openxmlformats.org/drawingml/2006/main"/>
+        </p:txBody>
       </p:sp>
       <p:sp>
         <p:nvSpPr>
@@ -11520,6 +11558,11 @@
             <a:prstDash val="solid"/>
           </a:ln>
         </p:spPr>
+        <p:txBody>
+          <a:bodyPr xmlns:a="http://schemas.openxmlformats.org/drawingml/2006/main"/>
+          <a:lstStyle xmlns:a="http://schemas.openxmlformats.org/drawingml/2006/main"/>
+          <a:p xmlns:a="http://schemas.openxmlformats.org/drawingml/2006/main"/>
+        </p:txBody>
       </p:sp>
       <p:sp>
         <p:nvSpPr>
@@ -11696,7 +11739,7 @@
                 <a:ea typeface="微软雅黑"/>
                 <a:cs typeface="微软雅黑"/>
               </a:rPr>
-              <a:t>真实课程样例：16 分钟播客与讲解视频已生成</a:t>
+              <a:t>真实课程样例：播客与带字幕讲解视频可直接播放</a:t>
             </a:r>
           </a:p>
         </p:txBody>
@@ -11786,7 +11829,7 @@
                 <a:ea typeface="微软雅黑"/>
                 <a:cs typeface="微软雅黑"/>
               </a:rPr>
-              <a:t>forgenote</a:t>
+              <a:t>Forgenote</a:t>
             </a:r>
           </a:p>
         </p:txBody>
@@ -11892,13 +11935,13 @@
           <p:nvPr/>
         </p:nvPicPr>
         <p:blipFill>
-          <a:blip xmlns:r="http://schemas.openxmlformats.org/officeDocument/2006/relationships" xmlns:a="http://schemas.openxmlformats.org/drawingml/2006/main" r:embed="R754f1291a42942fe"/>
+          <a:blip xmlns:r="http://schemas.openxmlformats.org/officeDocument/2006/relationships" xmlns:a="http://schemas.openxmlformats.org/drawingml/2006/main" r:embed="R865bbb31dd4f4233"/>
           <a:stretch xmlns:a="http://schemas.openxmlformats.org/drawingml/2006/main">
             <a:fillRect l="0" t="0" r="0" b="0"/>
           </a:stretch>
         </p:blipFill>
         <p:spPr>
-          <a:xfrm xmlns:a="http://schemas.openxmlformats.org/drawingml/2006/main" flipH="0" flipV="0">
+          <a:xfrm xmlns:a="http://schemas.openxmlformats.org/drawingml/2006/main">
             <a:off x="1136483" y="2057400"/>
             <a:ext cx="5880434" cy="3886200"/>
           </a:xfrm>
@@ -11993,8 +12036,9 @@
                 <a:latin typeface="微软雅黑"/>
                 <a:ea typeface="微软雅黑"/>
                 <a:cs typeface="微软雅黑"/>
+                <a:hlinkClick xmlns:r="http://schemas.openxmlformats.org/officeDocument/2006/relationships" r:id="R34278a78612e43b5"/>
               </a:rPr>
-              <a:t>完整播客 16:30</a:t>
+              <a:t>▶ 播放视频（含字幕）</a:t>
             </a:r>
           </a:p>
         </p:txBody>
@@ -12085,8 +12129,9 @@
                 <a:latin typeface="微软雅黑"/>
                 <a:ea typeface="微软雅黑"/>
                 <a:cs typeface="微软雅黑"/>
+                <a:hlinkClick xmlns:r="http://schemas.openxmlformats.org/officeDocument/2006/relationships" r:id="R48f290c061964baa"/>
               </a:rPr>
-              <a:t>中文讲解 33 段</a:t>
+              <a:t>▶ 播放播客（16:30）</a:t>
             </a:r>
           </a:p>
         </p:txBody>
@@ -12123,6 +12168,11 @@
             <a:prstDash val="solid"/>
           </a:ln>
         </p:spPr>
+        <p:txBody>
+          <a:bodyPr xmlns:a="http://schemas.openxmlformats.org/drawingml/2006/main"/>
+          <a:lstStyle xmlns:a="http://schemas.openxmlformats.org/drawingml/2006/main"/>
+          <a:p xmlns:a="http://schemas.openxmlformats.org/drawingml/2006/main"/>
+        </p:txBody>
       </p:sp>
       <p:sp>
         <p:nvSpPr>
@@ -12154,7 +12204,7 @@
         </p:spPr>
         <p:txBody>
           <a:bodyPr xmlns:a="http://schemas.openxmlformats.org/drawingml/2006/main" anchor="t">
-            <a:normAutofit fontScale="100000"/>
+            <a:normAutofit/>
           </a:bodyPr>
           <a:lstStyle xmlns:a="http://schemas.openxmlformats.org/drawingml/2006/main"/>
           <a:p xmlns:a="http://schemas.openxmlformats.org/drawingml/2006/main">
@@ -12270,25 +12320,25 @@
                 <a:ea typeface="微软雅黑"/>
                 <a:cs typeface="微软雅黑"/>
               </a:rPr>
-              <a:t>视频 1280 × 720</a:t>
+              <a:t>中文字幕 122 条</a:t>
             </a:r>
           </a:p>
         </p:txBody>
       </p:sp>
       <p:pic>
         <p:nvPicPr>
-          <p:cNvPr id="46" name=""/>
+          <p:cNvPr id="46" name="图片 45"/>
           <p:cNvPicPr>
             <a:picLocks xmlns:a="http://schemas.openxmlformats.org/drawingml/2006/main" noChangeAspect="1"/>
           </p:cNvPicPr>
           <p:nvPr/>
         </p:nvPicPr>
         <p:blipFill>
-          <a:blip xmlns:r="http://schemas.openxmlformats.org/officeDocument/2006/relationships" xmlns:a="http://schemas.openxmlformats.org/drawingml/2006/main" r:embed="R557a5b56a6884a4d"/>
+          <a:blip xmlns:r="http://schemas.openxmlformats.org/officeDocument/2006/relationships" xmlns:a="http://schemas.openxmlformats.org/drawingml/2006/main" r:embed="R9a84d82f1c6e4ed7"/>
           <a:stretch xmlns:a="http://schemas.openxmlformats.org/drawingml/2006/main"/>
         </p:blipFill>
         <p:spPr>
-          <a:xfrm xmlns:a="http://schemas.openxmlformats.org/drawingml/2006/main" flipH="0" flipV="0">
+          <a:xfrm xmlns:a="http://schemas.openxmlformats.org/drawingml/2006/main">
             <a:off x="1136483" y="2057400"/>
             <a:ext cx="5880434" cy="3886200"/>
           </a:xfrm>
@@ -12601,7 +12651,7 @@
         </p:spPr>
         <p:txBody>
           <a:bodyPr xmlns:a="http://schemas.openxmlformats.org/drawingml/2006/main" anchor="t">
-            <a:normAutofit fontScale="100000"/>
+            <a:normAutofit/>
           </a:bodyPr>
           <a:lstStyle xmlns:a="http://schemas.openxmlformats.org/drawingml/2006/main"/>
           <a:p xmlns:a="http://schemas.openxmlformats.org/drawingml/2006/main">
@@ -12684,7 +12734,7 @@
                 <a:ea typeface="微软雅黑"/>
                 <a:cs typeface="微软雅黑"/>
               </a:rPr>
-              <a:t>ForgeNote｜A3 个性化资源生成与学习多智能体系统</a:t>
+              <a:t>Forgenote｜A3 个性化资源生成与学习多智能体系统</a:t>
             </a:r>
           </a:p>
         </p:txBody>
@@ -12743,7 +12793,7 @@
                 <a:ea typeface="微软雅黑"/>
                 <a:cs typeface="微软雅黑"/>
               </a:rPr>
-              <a:t>forgenote</a:t>
+              <a:t>Forgenote</a:t>
             </a:r>
           </a:p>
         </p:txBody>
@@ -13194,7 +13244,7 @@
                 <a:ea typeface="微软雅黑"/>
                 <a:cs typeface="微软雅黑"/>
               </a:rPr>
-              <a:t>forgenote</a:t>
+              <a:t>Forgenote</a:t>
             </a:r>
           </a:p>
         </p:txBody>
@@ -13816,7 +13866,7 @@
           <p:nvPr/>
         </p:nvSpPr>
         <p:spPr>
-          <a:xfrm xmlns:a="http://schemas.openxmlformats.org/drawingml/2006/main" rot="0" flipH="0" flipV="0">
+          <a:xfrm xmlns:a="http://schemas.openxmlformats.org/drawingml/2006/main">
             <a:off x="6525390" y="2089266"/>
             <a:ext cx="4397884" cy="3855832"/>
           </a:xfrm>
@@ -13880,14 +13930,14 @@
           <p:nvPr/>
         </p:nvPicPr>
         <p:blipFill>
-          <a:blip xmlns:r="http://schemas.openxmlformats.org/officeDocument/2006/relationships" xmlns:a="http://schemas.openxmlformats.org/drawingml/2006/main" r:embed="R9146add2682a4c0b"/>
+          <a:blip xmlns:r="http://schemas.openxmlformats.org/officeDocument/2006/relationships" xmlns:a="http://schemas.openxmlformats.org/drawingml/2006/main" r:embed="R69092c09c047442b"/>
           <a:srcRect xmlns:a="http://schemas.openxmlformats.org/drawingml/2006/main" l="-17" t="11894" r="0" b="0"/>
           <a:stretch xmlns:a="http://schemas.openxmlformats.org/drawingml/2006/main">
             <a:fillRect l="0" t="0" r="0" b="0"/>
           </a:stretch>
         </p:blipFill>
         <p:spPr>
-          <a:xfrm xmlns:a="http://schemas.openxmlformats.org/drawingml/2006/main" rot="0" flipH="0" flipV="0">
+          <a:xfrm xmlns:a="http://schemas.openxmlformats.org/drawingml/2006/main">
             <a:off x="6648425" y="2204815"/>
             <a:ext cx="4128821" cy="3608609"/>
           </a:xfrm>
@@ -14285,7 +14335,7 @@
                 <a:ea typeface="微软雅黑"/>
                 <a:cs typeface="微软雅黑"/>
               </a:rPr>
-              <a:t>forgenote</a:t>
+              <a:t>Forgenote</a:t>
             </a:r>
           </a:p>
         </p:txBody>
@@ -14811,7 +14861,7 @@
           <p:nvPr/>
         </p:nvSpPr>
         <p:spPr>
-          <a:xfrm xmlns:a="http://schemas.openxmlformats.org/drawingml/2006/main" rot="0" flipH="0" flipV="0">
+          <a:xfrm xmlns:a="http://schemas.openxmlformats.org/drawingml/2006/main">
             <a:off x="6135861" y="1720088"/>
             <a:ext cx="5214452" cy="4536913"/>
           </a:xfrm>
@@ -14974,14 +15024,14 @@
           <p:nvPr/>
         </p:nvPicPr>
         <p:blipFill>
-          <a:blip xmlns:r="http://schemas.openxmlformats.org/officeDocument/2006/relationships" xmlns:a="http://schemas.openxmlformats.org/drawingml/2006/main" r:embed="R5326ef00959d47bb"/>
+          <a:blip xmlns:r="http://schemas.openxmlformats.org/officeDocument/2006/relationships" xmlns:a="http://schemas.openxmlformats.org/drawingml/2006/main" r:embed="R7339b888523f4d70"/>
           <a:srcRect xmlns:a="http://schemas.openxmlformats.org/drawingml/2006/main" l="2687" t="0" r="2687" b="0"/>
           <a:stretch xmlns:a="http://schemas.openxmlformats.org/drawingml/2006/main">
             <a:fillRect l="0" t="0" r="0" b="0"/>
           </a:stretch>
         </p:blipFill>
         <p:spPr>
-          <a:xfrm xmlns:a="http://schemas.openxmlformats.org/drawingml/2006/main" rot="0" flipH="0" flipV="0">
+          <a:xfrm xmlns:a="http://schemas.openxmlformats.org/drawingml/2006/main">
             <a:off x="6455127" y="1988820"/>
             <a:ext cx="4576269" cy="4000500"/>
           </a:xfrm>
@@ -15405,7 +15455,7 @@
                 <a:ea typeface="微软雅黑"/>
                 <a:cs typeface="微软雅黑"/>
               </a:rPr>
-              <a:t>forgenote</a:t>
+              <a:t>Forgenote</a:t>
             </a:r>
           </a:p>
         </p:txBody>
@@ -16307,7 +16357,7 @@
                 <a:ea typeface="微软雅黑"/>
                 <a:cs typeface="微软雅黑"/>
               </a:rPr>
-              <a:t>forgenote</a:t>
+              <a:t>Forgenote</a:t>
             </a:r>
           </a:p>
         </p:txBody>
@@ -18296,7 +18346,7 @@
         </p:spPr>
         <p:txBody>
           <a:bodyPr xmlns:a="http://schemas.openxmlformats.org/drawingml/2006/main" anchor="t">
-            <a:normAutofit fontScale="100000"/>
+            <a:normAutofit/>
           </a:bodyPr>
           <a:lstStyle xmlns:a="http://schemas.openxmlformats.org/drawingml/2006/main"/>
           <a:p xmlns:a="http://schemas.openxmlformats.org/drawingml/2006/main">
@@ -18410,7 +18460,7 @@
                 <a:ea typeface="微软雅黑"/>
                 <a:cs typeface="微软雅黑"/>
               </a:rPr>
-              <a:t>forgenote</a:t>
+              <a:t>Forgenote</a:t>
             </a:r>
           </a:p>
         </p:txBody>
@@ -18594,7 +18644,7 @@
         </p:spPr>
         <p:txBody>
           <a:bodyPr xmlns:a="http://schemas.openxmlformats.org/drawingml/2006/main" anchor="t">
-            <a:normAutofit fontScale="100000"/>
+            <a:normAutofit/>
           </a:bodyPr>
           <a:lstStyle xmlns:a="http://schemas.openxmlformats.org/drawingml/2006/main"/>
           <a:p xmlns:a="http://schemas.openxmlformats.org/drawingml/2006/main">
@@ -18743,7 +18793,7 @@
         </p:spPr>
         <p:txBody>
           <a:bodyPr xmlns:a="http://schemas.openxmlformats.org/drawingml/2006/main" anchor="t">
-            <a:normAutofit fontScale="100000"/>
+            <a:normAutofit/>
           </a:bodyPr>
           <a:lstStyle xmlns:a="http://schemas.openxmlformats.org/drawingml/2006/main"/>
           <a:p xmlns:a="http://schemas.openxmlformats.org/drawingml/2006/main">
@@ -18892,7 +18942,7 @@
         </p:spPr>
         <p:txBody>
           <a:bodyPr xmlns:a="http://schemas.openxmlformats.org/drawingml/2006/main" anchor="t">
-            <a:normAutofit fontScale="100000"/>
+            <a:normAutofit/>
           </a:bodyPr>
           <a:lstStyle xmlns:a="http://schemas.openxmlformats.org/drawingml/2006/main"/>
           <a:p xmlns:a="http://schemas.openxmlformats.org/drawingml/2006/main">
@@ -19225,7 +19275,7 @@
         </p:spPr>
         <p:txBody>
           <a:bodyPr xmlns:a="http://schemas.openxmlformats.org/drawingml/2006/main" anchor="t">
-            <a:normAutofit fontScale="100000"/>
+            <a:normAutofit/>
           </a:bodyPr>
           <a:lstStyle xmlns:a="http://schemas.openxmlformats.org/drawingml/2006/main"/>
           <a:p xmlns:a="http://schemas.openxmlformats.org/drawingml/2006/main">
@@ -19339,7 +19389,7 @@
                 <a:ea typeface="微软雅黑"/>
                 <a:cs typeface="微软雅黑"/>
               </a:rPr>
-              <a:t>forgenote</a:t>
+              <a:t>Forgenote</a:t>
             </a:r>
           </a:p>
         </p:txBody>
@@ -19525,7 +19575,7 @@
         </p:spPr>
         <p:txBody>
           <a:bodyPr xmlns:a="http://schemas.openxmlformats.org/drawingml/2006/main" anchor="t">
-            <a:normAutofit fontScale="100000"/>
+            <a:normAutofit/>
           </a:bodyPr>
           <a:lstStyle xmlns:a="http://schemas.openxmlformats.org/drawingml/2006/main"/>
           <a:p xmlns:a="http://schemas.openxmlformats.org/drawingml/2006/main">
@@ -19978,7 +20028,7 @@
         </p:spPr>
         <p:txBody>
           <a:bodyPr xmlns:a="http://schemas.openxmlformats.org/drawingml/2006/main" anchor="t">
-            <a:normAutofit fontScale="100000"/>
+            <a:normAutofit/>
           </a:bodyPr>
           <a:lstStyle xmlns:a="http://schemas.openxmlformats.org/drawingml/2006/main"/>
           <a:p xmlns:a="http://schemas.openxmlformats.org/drawingml/2006/main">
@@ -20613,7 +20663,7 @@
         </p:spPr>
         <p:txBody>
           <a:bodyPr xmlns:a="http://schemas.openxmlformats.org/drawingml/2006/main" anchor="t">
-            <a:normAutofit fontScale="100000"/>
+            <a:normAutofit/>
           </a:bodyPr>
           <a:lstStyle xmlns:a="http://schemas.openxmlformats.org/drawingml/2006/main"/>
           <a:p xmlns:a="http://schemas.openxmlformats.org/drawingml/2006/main">
@@ -20727,7 +20777,7 @@
                 <a:ea typeface="微软雅黑"/>
                 <a:cs typeface="微软雅黑"/>
               </a:rPr>
-              <a:t>forgenote</a:t>
+              <a:t>Forgenote</a:t>
             </a:r>
           </a:p>
         </p:txBody>
@@ -20911,7 +20961,7 @@
         </p:spPr>
         <p:txBody>
           <a:bodyPr xmlns:a="http://schemas.openxmlformats.org/drawingml/2006/main" anchor="t">
-            <a:normAutofit fontScale="100000"/>
+            <a:normAutofit/>
           </a:bodyPr>
           <a:lstStyle xmlns:a="http://schemas.openxmlformats.org/drawingml/2006/main"/>
           <a:p xmlns:a="http://schemas.openxmlformats.org/drawingml/2006/main">
@@ -21060,7 +21110,7 @@
         </p:spPr>
         <p:txBody>
           <a:bodyPr xmlns:a="http://schemas.openxmlformats.org/drawingml/2006/main" anchor="t">
-            <a:normAutofit fontScale="100000"/>
+            <a:normAutofit/>
           </a:bodyPr>
           <a:lstStyle xmlns:a="http://schemas.openxmlformats.org/drawingml/2006/main"/>
           <a:p xmlns:a="http://schemas.openxmlformats.org/drawingml/2006/main">
@@ -21209,7 +21259,7 @@
         </p:spPr>
         <p:txBody>
           <a:bodyPr xmlns:a="http://schemas.openxmlformats.org/drawingml/2006/main" anchor="t">
-            <a:normAutofit fontScale="100000"/>
+            <a:normAutofit/>
           </a:bodyPr>
           <a:lstStyle xmlns:a="http://schemas.openxmlformats.org/drawingml/2006/main"/>
           <a:p xmlns:a="http://schemas.openxmlformats.org/drawingml/2006/main">
@@ -21656,7 +21706,7 @@
                 <a:ea typeface="微软雅黑"/>
                 <a:cs typeface="微软雅黑"/>
               </a:rPr>
-              <a:t>forgenote</a:t>
+              <a:t>Forgenote</a:t>
             </a:r>
           </a:p>
         </p:txBody>

</xml_diff>